<commit_message>
Update Pics and Instructions - Enclosure and Digital I-O
</commit_message>
<xml_diff>
--- a/content/Extras/OT_Demo_Lab/How_To_Build_Enclosure/Wiring_Topology.pptx
+++ b/content/Extras/OT_Demo_Lab/How_To_Build_Enclosure/Wiring_Topology.pptx
@@ -6,6 +6,7 @@
   </p:sldMasterIdLst>
   <p:sldIdLst>
     <p:sldId id="256" r:id="rId2"/>
+    <p:sldId id="257" r:id="rId3"/>
   </p:sldIdLst>
   <p:sldSz cx="12192000" cy="6858000"/>
   <p:notesSz cx="6858000" cy="9144000"/>
@@ -259,7 +260,7 @@
           <a:p>
             <a:fld id="{96B3FE1A-EE29-4ECA-A931-EC808BB2D402}" type="datetimeFigureOut">
               <a:rPr lang="en-US" smtClean="0"/>
-              <a:t>6/18/2026</a:t>
+              <a:t>6/28/2026</a:t>
             </a:fld>
             <a:endParaRPr lang="en-US"/>
           </a:p>
@@ -457,7 +458,7 @@
           <a:p>
             <a:fld id="{96B3FE1A-EE29-4ECA-A931-EC808BB2D402}" type="datetimeFigureOut">
               <a:rPr lang="en-US" smtClean="0"/>
-              <a:t>6/18/2026</a:t>
+              <a:t>6/28/2026</a:t>
             </a:fld>
             <a:endParaRPr lang="en-US"/>
           </a:p>
@@ -665,7 +666,7 @@
           <a:p>
             <a:fld id="{96B3FE1A-EE29-4ECA-A931-EC808BB2D402}" type="datetimeFigureOut">
               <a:rPr lang="en-US" smtClean="0"/>
-              <a:t>6/18/2026</a:t>
+              <a:t>6/28/2026</a:t>
             </a:fld>
             <a:endParaRPr lang="en-US"/>
           </a:p>
@@ -863,7 +864,7 @@
           <a:p>
             <a:fld id="{96B3FE1A-EE29-4ECA-A931-EC808BB2D402}" type="datetimeFigureOut">
               <a:rPr lang="en-US" smtClean="0"/>
-              <a:t>6/18/2026</a:t>
+              <a:t>6/28/2026</a:t>
             </a:fld>
             <a:endParaRPr lang="en-US"/>
           </a:p>
@@ -1138,7 +1139,7 @@
           <a:p>
             <a:fld id="{96B3FE1A-EE29-4ECA-A931-EC808BB2D402}" type="datetimeFigureOut">
               <a:rPr lang="en-US" smtClean="0"/>
-              <a:t>6/18/2026</a:t>
+              <a:t>6/28/2026</a:t>
             </a:fld>
             <a:endParaRPr lang="en-US"/>
           </a:p>
@@ -1403,7 +1404,7 @@
           <a:p>
             <a:fld id="{96B3FE1A-EE29-4ECA-A931-EC808BB2D402}" type="datetimeFigureOut">
               <a:rPr lang="en-US" smtClean="0"/>
-              <a:t>6/18/2026</a:t>
+              <a:t>6/28/2026</a:t>
             </a:fld>
             <a:endParaRPr lang="en-US"/>
           </a:p>
@@ -1815,7 +1816,7 @@
           <a:p>
             <a:fld id="{96B3FE1A-EE29-4ECA-A931-EC808BB2D402}" type="datetimeFigureOut">
               <a:rPr lang="en-US" smtClean="0"/>
-              <a:t>6/18/2026</a:t>
+              <a:t>6/28/2026</a:t>
             </a:fld>
             <a:endParaRPr lang="en-US"/>
           </a:p>
@@ -1956,7 +1957,7 @@
           <a:p>
             <a:fld id="{96B3FE1A-EE29-4ECA-A931-EC808BB2D402}" type="datetimeFigureOut">
               <a:rPr lang="en-US" smtClean="0"/>
-              <a:t>6/18/2026</a:t>
+              <a:t>6/28/2026</a:t>
             </a:fld>
             <a:endParaRPr lang="en-US"/>
           </a:p>
@@ -2069,7 +2070,7 @@
           <a:p>
             <a:fld id="{96B3FE1A-EE29-4ECA-A931-EC808BB2D402}" type="datetimeFigureOut">
               <a:rPr lang="en-US" smtClean="0"/>
-              <a:t>6/18/2026</a:t>
+              <a:t>6/28/2026</a:t>
             </a:fld>
             <a:endParaRPr lang="en-US"/>
           </a:p>
@@ -2380,7 +2381,7 @@
           <a:p>
             <a:fld id="{96B3FE1A-EE29-4ECA-A931-EC808BB2D402}" type="datetimeFigureOut">
               <a:rPr lang="en-US" smtClean="0"/>
-              <a:t>6/18/2026</a:t>
+              <a:t>6/28/2026</a:t>
             </a:fld>
             <a:endParaRPr lang="en-US"/>
           </a:p>
@@ -2668,7 +2669,7 @@
           <a:p>
             <a:fld id="{96B3FE1A-EE29-4ECA-A931-EC808BB2D402}" type="datetimeFigureOut">
               <a:rPr lang="en-US" smtClean="0"/>
-              <a:t>6/18/2026</a:t>
+              <a:t>6/28/2026</a:t>
             </a:fld>
             <a:endParaRPr lang="en-US"/>
           </a:p>
@@ -2909,7 +2910,7 @@
           <a:p>
             <a:fld id="{96B3FE1A-EE29-4ECA-A931-EC808BB2D402}" type="datetimeFigureOut">
               <a:rPr lang="en-US" smtClean="0"/>
-              <a:t>6/18/2026</a:t>
+              <a:t>6/28/2026</a:t>
             </a:fld>
             <a:endParaRPr lang="en-US"/>
           </a:p>
@@ -3498,10 +3499,10 @@
       </p:pic>
       <p:pic>
         <p:nvPicPr>
-          <p:cNvPr id="7" name="Picture 6">
-            <a:extLst>
-              <a:ext uri="{FF2B5EF4-FFF2-40B4-BE49-F238E27FC236}">
-                <a16:creationId xmlns:a16="http://schemas.microsoft.com/office/drawing/2014/main" id="{3F1CC1E9-6CA9-488B-BC1C-FBAD1F5F4690}"/>
+          <p:cNvPr id="9" name="Picture 8">
+            <a:extLst>
+              <a:ext uri="{FF2B5EF4-FFF2-40B4-BE49-F238E27FC236}">
+                <a16:creationId xmlns:a16="http://schemas.microsoft.com/office/drawing/2014/main" id="{25EBA850-ADBA-BB97-7219-718DA84E8325}"/>
               </a:ext>
             </a:extLst>
           </p:cNvPr>
@@ -3518,8 +3519,8 @@
         </p:blipFill>
         <p:spPr>
           <a:xfrm>
-            <a:off x="3079741" y="4665490"/>
-            <a:ext cx="803969" cy="836784"/>
+            <a:off x="9510066" y="2435119"/>
+            <a:ext cx="504895" cy="743054"/>
           </a:xfrm>
           <a:prstGeom prst="rect">
             <a:avLst/>
@@ -3528,10 +3529,40 @@
       </p:pic>
       <p:pic>
         <p:nvPicPr>
-          <p:cNvPr id="9" name="Picture 8">
-            <a:extLst>
-              <a:ext uri="{FF2B5EF4-FFF2-40B4-BE49-F238E27FC236}">
-                <a16:creationId xmlns:a16="http://schemas.microsoft.com/office/drawing/2014/main" id="{25EBA850-ADBA-BB97-7219-718DA84E8325}"/>
+          <p:cNvPr id="11" name="Picture 10">
+            <a:extLst>
+              <a:ext uri="{FF2B5EF4-FFF2-40B4-BE49-F238E27FC236}">
+                <a16:creationId xmlns:a16="http://schemas.microsoft.com/office/drawing/2014/main" id="{36F31B0E-25BC-AABC-9059-0390F7C7D435}"/>
+              </a:ext>
+            </a:extLst>
+          </p:cNvPr>
+          <p:cNvPicPr>
+            <a:picLocks noChangeAspect="1"/>
+          </p:cNvPicPr>
+          <p:nvPr/>
+        </p:nvPicPr>
+        <p:blipFill>
+          <a:blip r:embed="rId3"/>
+          <a:stretch>
+            <a:fillRect/>
+          </a:stretch>
+        </p:blipFill>
+        <p:spPr>
+          <a:xfrm>
+            <a:off x="3357118" y="1746587"/>
+            <a:ext cx="504895" cy="743054"/>
+          </a:xfrm>
+          <a:prstGeom prst="rect">
+            <a:avLst/>
+          </a:prstGeom>
+        </p:spPr>
+      </p:pic>
+      <p:pic>
+        <p:nvPicPr>
+          <p:cNvPr id="13" name="Picture 12">
+            <a:extLst>
+              <a:ext uri="{FF2B5EF4-FFF2-40B4-BE49-F238E27FC236}">
+                <a16:creationId xmlns:a16="http://schemas.microsoft.com/office/drawing/2014/main" id="{0705EC08-9763-42A9-20E7-E81A8FF4C190}"/>
               </a:ext>
             </a:extLst>
           </p:cNvPr>
@@ -3548,66 +3579,6 @@
         </p:blipFill>
         <p:spPr>
           <a:xfrm>
-            <a:off x="9510066" y="2435119"/>
-            <a:ext cx="504895" cy="743054"/>
-          </a:xfrm>
-          <a:prstGeom prst="rect">
-            <a:avLst/>
-          </a:prstGeom>
-        </p:spPr>
-      </p:pic>
-      <p:pic>
-        <p:nvPicPr>
-          <p:cNvPr id="11" name="Picture 10">
-            <a:extLst>
-              <a:ext uri="{FF2B5EF4-FFF2-40B4-BE49-F238E27FC236}">
-                <a16:creationId xmlns:a16="http://schemas.microsoft.com/office/drawing/2014/main" id="{36F31B0E-25BC-AABC-9059-0390F7C7D435}"/>
-              </a:ext>
-            </a:extLst>
-          </p:cNvPr>
-          <p:cNvPicPr>
-            <a:picLocks noChangeAspect="1"/>
-          </p:cNvPicPr>
-          <p:nvPr/>
-        </p:nvPicPr>
-        <p:blipFill>
-          <a:blip r:embed="rId4"/>
-          <a:stretch>
-            <a:fillRect/>
-          </a:stretch>
-        </p:blipFill>
-        <p:spPr>
-          <a:xfrm>
-            <a:off x="3357118" y="1746587"/>
-            <a:ext cx="504895" cy="743054"/>
-          </a:xfrm>
-          <a:prstGeom prst="rect">
-            <a:avLst/>
-          </a:prstGeom>
-        </p:spPr>
-      </p:pic>
-      <p:pic>
-        <p:nvPicPr>
-          <p:cNvPr id="13" name="Picture 12">
-            <a:extLst>
-              <a:ext uri="{FF2B5EF4-FFF2-40B4-BE49-F238E27FC236}">
-                <a16:creationId xmlns:a16="http://schemas.microsoft.com/office/drawing/2014/main" id="{0705EC08-9763-42A9-20E7-E81A8FF4C190}"/>
-              </a:ext>
-            </a:extLst>
-          </p:cNvPr>
-          <p:cNvPicPr>
-            <a:picLocks noChangeAspect="1"/>
-          </p:cNvPicPr>
-          <p:nvPr/>
-        </p:nvPicPr>
-        <p:blipFill>
-          <a:blip r:embed="rId5"/>
-          <a:stretch>
-            <a:fillRect/>
-          </a:stretch>
-        </p:blipFill>
-        <p:spPr>
-          <a:xfrm>
             <a:off x="5178665" y="3997559"/>
             <a:ext cx="971546" cy="1956586"/>
           </a:xfrm>
@@ -3631,7 +3602,7 @@
           <p:nvPr/>
         </p:nvPicPr>
         <p:blipFill>
-          <a:blip r:embed="rId5"/>
+          <a:blip r:embed="rId4"/>
           <a:stretch>
             <a:fillRect/>
           </a:stretch>
@@ -4304,7 +4275,6 @@
           </p:cNvPr>
           <p:cNvCxnSpPr>
             <a:cxnSpLocks/>
-            <a:endCxn id="7" idx="0"/>
           </p:cNvCxnSpPr>
           <p:nvPr/>
         </p:nvCxnSpPr>
@@ -4867,7 +4837,7 @@
           <p:nvPr/>
         </p:nvPicPr>
         <p:blipFill>
-          <a:blip r:embed="rId6"/>
+          <a:blip r:embed="rId5"/>
           <a:stretch>
             <a:fillRect/>
           </a:stretch>
@@ -4897,7 +4867,7 @@
           <p:nvPr/>
         </p:nvPicPr>
         <p:blipFill>
-          <a:blip r:embed="rId7"/>
+          <a:blip r:embed="rId6"/>
           <a:stretch>
             <a:fillRect/>
           </a:stretch>
@@ -7595,10 +7565,3660 @@
           </a:fontRef>
         </p:style>
       </p:cxnSp>
+      <p:pic>
+        <p:nvPicPr>
+          <p:cNvPr id="6" name="Picture 5">
+            <a:extLst>
+              <a:ext uri="{FF2B5EF4-FFF2-40B4-BE49-F238E27FC236}">
+                <a16:creationId xmlns:a16="http://schemas.microsoft.com/office/drawing/2014/main" id="{53DE9AFF-0AF1-6503-06C6-5C92F748D5DA}"/>
+              </a:ext>
+            </a:extLst>
+          </p:cNvPr>
+          <p:cNvPicPr>
+            <a:picLocks noChangeAspect="1"/>
+          </p:cNvPicPr>
+          <p:nvPr/>
+        </p:nvPicPr>
+        <p:blipFill>
+          <a:blip r:embed="rId7"/>
+          <a:stretch>
+            <a:fillRect/>
+          </a:stretch>
+        </p:blipFill>
+        <p:spPr>
+          <a:xfrm>
+            <a:off x="3066337" y="4687160"/>
+            <a:ext cx="790632" cy="758825"/>
+          </a:xfrm>
+          <a:prstGeom prst="rect">
+            <a:avLst/>
+          </a:prstGeom>
+        </p:spPr>
+      </p:pic>
     </p:spTree>
     <p:extLst>
       <p:ext uri="{BB962C8B-B14F-4D97-AF65-F5344CB8AC3E}">
         <p14:creationId xmlns:p14="http://schemas.microsoft.com/office/powerpoint/2010/main" val="421152128"/>
+      </p:ext>
+    </p:extLst>
+  </p:cSld>
+  <p:clrMapOvr>
+    <a:masterClrMapping/>
+  </p:clrMapOvr>
+</p:sld>
+</file>
+
+<file path=ppt/slides/slide2.xml><?xml version="1.0" encoding="utf-8"?>
+<p:sld xmlns:a="http://schemas.openxmlformats.org/drawingml/2006/main" xmlns:r="http://schemas.openxmlformats.org/officeDocument/2006/relationships" xmlns:p="http://schemas.openxmlformats.org/presentationml/2006/main">
+  <p:cSld>
+    <p:spTree>
+      <p:nvGrpSpPr>
+        <p:cNvPr id="1" name="">
+          <a:extLst>
+            <a:ext uri="{FF2B5EF4-FFF2-40B4-BE49-F238E27FC236}">
+              <a16:creationId xmlns:a16="http://schemas.microsoft.com/office/drawing/2014/main" id="{229E7644-EE27-F10F-EEA3-FCFE51967CDD}"/>
+            </a:ext>
+          </a:extLst>
+        </p:cNvPr>
+        <p:cNvGrpSpPr/>
+        <p:nvPr/>
+      </p:nvGrpSpPr>
+      <p:grpSpPr>
+        <a:xfrm>
+          <a:off x="0" y="0"/>
+          <a:ext cx="0" cy="0"/>
+          <a:chOff x="0" y="0"/>
+          <a:chExt cx="0" cy="0"/>
+        </a:xfrm>
+      </p:grpSpPr>
+      <p:sp>
+        <p:nvSpPr>
+          <p:cNvPr id="35" name="TextBox 34">
+            <a:extLst>
+              <a:ext uri="{FF2B5EF4-FFF2-40B4-BE49-F238E27FC236}">
+                <a16:creationId xmlns:a16="http://schemas.microsoft.com/office/drawing/2014/main" id="{5480CFD0-C83E-460C-A142-6BD151E948CD}"/>
+              </a:ext>
+            </a:extLst>
+          </p:cNvPr>
+          <p:cNvSpPr txBox="1"/>
+          <p:nvPr/>
+        </p:nvSpPr>
+        <p:spPr>
+          <a:xfrm>
+            <a:off x="3035627" y="5982800"/>
+            <a:ext cx="831515" cy="215444"/>
+          </a:xfrm>
+          <a:prstGeom prst="rect">
+            <a:avLst/>
+          </a:prstGeom>
+          <a:noFill/>
+        </p:spPr>
+        <p:txBody>
+          <a:bodyPr wrap="square" rtlCol="0">
+            <a:spAutoFit/>
+          </a:bodyPr>
+          <a:lstStyle/>
+          <a:p>
+            <a:r>
+              <a:rPr lang="en-US" sz="800" dirty="0"/>
+              <a:t>Line / Black</a:t>
+            </a:r>
+          </a:p>
+        </p:txBody>
+      </p:sp>
+      <p:sp>
+        <p:nvSpPr>
+          <p:cNvPr id="33" name="TextBox 32">
+            <a:extLst>
+              <a:ext uri="{FF2B5EF4-FFF2-40B4-BE49-F238E27FC236}">
+                <a16:creationId xmlns:a16="http://schemas.microsoft.com/office/drawing/2014/main" id="{A5AF529A-6BEF-8298-8C85-5382BB715FB9}"/>
+              </a:ext>
+            </a:extLst>
+          </p:cNvPr>
+          <p:cNvSpPr txBox="1"/>
+          <p:nvPr/>
+        </p:nvSpPr>
+        <p:spPr>
+          <a:xfrm>
+            <a:off x="2655606" y="5857179"/>
+            <a:ext cx="923416" cy="215444"/>
+          </a:xfrm>
+          <a:prstGeom prst="rect">
+            <a:avLst/>
+          </a:prstGeom>
+          <a:noFill/>
+        </p:spPr>
+        <p:txBody>
+          <a:bodyPr wrap="square" rtlCol="0">
+            <a:spAutoFit/>
+          </a:bodyPr>
+          <a:lstStyle/>
+          <a:p>
+            <a:r>
+              <a:rPr lang="en-US" sz="800" dirty="0"/>
+              <a:t>Neutral / White</a:t>
+            </a:r>
+          </a:p>
+        </p:txBody>
+      </p:sp>
+      <p:sp>
+        <p:nvSpPr>
+          <p:cNvPr id="31" name="TextBox 30">
+            <a:extLst>
+              <a:ext uri="{FF2B5EF4-FFF2-40B4-BE49-F238E27FC236}">
+                <a16:creationId xmlns:a16="http://schemas.microsoft.com/office/drawing/2014/main" id="{2A1A150C-DF85-9AAD-9187-083D53683370}"/>
+              </a:ext>
+            </a:extLst>
+          </p:cNvPr>
+          <p:cNvSpPr txBox="1"/>
+          <p:nvPr/>
+        </p:nvSpPr>
+        <p:spPr>
+          <a:xfrm>
+            <a:off x="2444235" y="5719565"/>
+            <a:ext cx="879515" cy="215444"/>
+          </a:xfrm>
+          <a:prstGeom prst="rect">
+            <a:avLst/>
+          </a:prstGeom>
+          <a:noFill/>
+        </p:spPr>
+        <p:txBody>
+          <a:bodyPr wrap="square" rtlCol="0">
+            <a:spAutoFit/>
+          </a:bodyPr>
+          <a:lstStyle/>
+          <a:p>
+            <a:r>
+              <a:rPr lang="en-US" sz="800" dirty="0"/>
+              <a:t>Ground / Green</a:t>
+            </a:r>
+          </a:p>
+        </p:txBody>
+      </p:sp>
+      <p:sp>
+        <p:nvSpPr>
+          <p:cNvPr id="79" name="TextBox 78">
+            <a:extLst>
+              <a:ext uri="{FF2B5EF4-FFF2-40B4-BE49-F238E27FC236}">
+                <a16:creationId xmlns:a16="http://schemas.microsoft.com/office/drawing/2014/main" id="{C5B2F6DD-C9BB-886A-3551-7257161B9D20}"/>
+              </a:ext>
+            </a:extLst>
+          </p:cNvPr>
+          <p:cNvSpPr txBox="1"/>
+          <p:nvPr/>
+        </p:nvSpPr>
+        <p:spPr>
+          <a:xfrm>
+            <a:off x="5611456" y="6000035"/>
+            <a:ext cx="713071" cy="215444"/>
+          </a:xfrm>
+          <a:prstGeom prst="rect">
+            <a:avLst/>
+          </a:prstGeom>
+          <a:noFill/>
+        </p:spPr>
+        <p:txBody>
+          <a:bodyPr wrap="square" rtlCol="0">
+            <a:spAutoFit/>
+          </a:bodyPr>
+          <a:lstStyle/>
+          <a:p>
+            <a:r>
+              <a:rPr lang="en-US" sz="800" dirty="0"/>
+              <a:t>G3  N3    L3</a:t>
+            </a:r>
+          </a:p>
+        </p:txBody>
+      </p:sp>
+      <p:pic>
+        <p:nvPicPr>
+          <p:cNvPr id="5" name="Picture 4">
+            <a:extLst>
+              <a:ext uri="{FF2B5EF4-FFF2-40B4-BE49-F238E27FC236}">
+                <a16:creationId xmlns:a16="http://schemas.microsoft.com/office/drawing/2014/main" id="{43FB169A-3ED8-49B4-DAD2-50C0163A915A}"/>
+              </a:ext>
+            </a:extLst>
+          </p:cNvPr>
+          <p:cNvPicPr>
+            <a:picLocks noChangeAspect="1"/>
+          </p:cNvPicPr>
+          <p:nvPr/>
+        </p:nvPicPr>
+        <p:blipFill>
+          <a:blip r:embed="rId2"/>
+          <a:stretch>
+            <a:fillRect/>
+          </a:stretch>
+        </p:blipFill>
+        <p:spPr>
+          <a:xfrm>
+            <a:off x="1589295" y="5467191"/>
+            <a:ext cx="789243" cy="935635"/>
+          </a:xfrm>
+          <a:prstGeom prst="rect">
+            <a:avLst/>
+          </a:prstGeom>
+        </p:spPr>
+      </p:pic>
+      <p:cxnSp>
+        <p:nvCxnSpPr>
+          <p:cNvPr id="19" name="Straight Connector 18">
+            <a:extLst>
+              <a:ext uri="{FF2B5EF4-FFF2-40B4-BE49-F238E27FC236}">
+                <a16:creationId xmlns:a16="http://schemas.microsoft.com/office/drawing/2014/main" id="{DD16B577-5017-3D05-1FBF-2672ABC9033E}"/>
+              </a:ext>
+            </a:extLst>
+          </p:cNvPr>
+          <p:cNvCxnSpPr/>
+          <p:nvPr/>
+        </p:nvCxnSpPr>
+        <p:spPr>
+          <a:xfrm>
+            <a:off x="2821856" y="5887218"/>
+            <a:ext cx="576242" cy="0"/>
+          </a:xfrm>
+          <a:prstGeom prst="line">
+            <a:avLst/>
+          </a:prstGeom>
+          <a:ln>
+            <a:solidFill>
+              <a:schemeClr val="accent3">
+                <a:lumMod val="60000"/>
+                <a:lumOff val="40000"/>
+              </a:schemeClr>
+            </a:solidFill>
+          </a:ln>
+        </p:spPr>
+        <p:style>
+          <a:lnRef idx="2">
+            <a:schemeClr val="accent1"/>
+          </a:lnRef>
+          <a:fillRef idx="0">
+            <a:schemeClr val="accent1"/>
+          </a:fillRef>
+          <a:effectRef idx="1">
+            <a:schemeClr val="accent1"/>
+          </a:effectRef>
+          <a:fontRef idx="minor">
+            <a:schemeClr val="tx1"/>
+          </a:fontRef>
+        </p:style>
+      </p:cxnSp>
+      <p:cxnSp>
+        <p:nvCxnSpPr>
+          <p:cNvPr id="20" name="Straight Connector 19">
+            <a:extLst>
+              <a:ext uri="{FF2B5EF4-FFF2-40B4-BE49-F238E27FC236}">
+                <a16:creationId xmlns:a16="http://schemas.microsoft.com/office/drawing/2014/main" id="{8FDD5C49-09D2-E8F0-66CB-9C28B7CA0889}"/>
+              </a:ext>
+            </a:extLst>
+          </p:cNvPr>
+          <p:cNvCxnSpPr>
+            <a:cxnSpLocks/>
+          </p:cNvCxnSpPr>
+          <p:nvPr/>
+        </p:nvCxnSpPr>
+        <p:spPr>
+          <a:xfrm>
+            <a:off x="3398098" y="5474520"/>
+            <a:ext cx="0" cy="412698"/>
+          </a:xfrm>
+          <a:prstGeom prst="line">
+            <a:avLst/>
+          </a:prstGeom>
+          <a:ln>
+            <a:solidFill>
+              <a:schemeClr val="accent3">
+                <a:lumMod val="60000"/>
+                <a:lumOff val="40000"/>
+              </a:schemeClr>
+            </a:solidFill>
+          </a:ln>
+        </p:spPr>
+        <p:style>
+          <a:lnRef idx="2">
+            <a:schemeClr val="accent1"/>
+          </a:lnRef>
+          <a:fillRef idx="0">
+            <a:schemeClr val="accent1"/>
+          </a:fillRef>
+          <a:effectRef idx="1">
+            <a:schemeClr val="accent1"/>
+          </a:effectRef>
+          <a:fontRef idx="minor">
+            <a:schemeClr val="tx1"/>
+          </a:fontRef>
+        </p:style>
+      </p:cxnSp>
+      <p:cxnSp>
+        <p:nvCxnSpPr>
+          <p:cNvPr id="23" name="Straight Connector 22">
+            <a:extLst>
+              <a:ext uri="{FF2B5EF4-FFF2-40B4-BE49-F238E27FC236}">
+                <a16:creationId xmlns:a16="http://schemas.microsoft.com/office/drawing/2014/main" id="{102AF49A-FD2B-85EE-C163-07D7CC54D3B8}"/>
+              </a:ext>
+            </a:extLst>
+          </p:cNvPr>
+          <p:cNvCxnSpPr/>
+          <p:nvPr/>
+        </p:nvCxnSpPr>
+        <p:spPr>
+          <a:xfrm>
+            <a:off x="3068477" y="6027127"/>
+            <a:ext cx="576242" cy="0"/>
+          </a:xfrm>
+          <a:prstGeom prst="line">
+            <a:avLst/>
+          </a:prstGeom>
+          <a:ln>
+            <a:solidFill>
+              <a:srgbClr val="FF0000"/>
+            </a:solidFill>
+          </a:ln>
+        </p:spPr>
+        <p:style>
+          <a:lnRef idx="2">
+            <a:schemeClr val="accent1"/>
+          </a:lnRef>
+          <a:fillRef idx="0">
+            <a:schemeClr val="accent1"/>
+          </a:fillRef>
+          <a:effectRef idx="1">
+            <a:schemeClr val="accent1"/>
+          </a:effectRef>
+          <a:fontRef idx="minor">
+            <a:schemeClr val="tx1"/>
+          </a:fontRef>
+        </p:style>
+      </p:cxnSp>
+      <p:cxnSp>
+        <p:nvCxnSpPr>
+          <p:cNvPr id="24" name="Straight Connector 23">
+            <a:extLst>
+              <a:ext uri="{FF2B5EF4-FFF2-40B4-BE49-F238E27FC236}">
+                <a16:creationId xmlns:a16="http://schemas.microsoft.com/office/drawing/2014/main" id="{DA07B689-A9C5-162A-89F8-E9D5404C167D}"/>
+              </a:ext>
+            </a:extLst>
+          </p:cNvPr>
+          <p:cNvCxnSpPr>
+            <a:cxnSpLocks/>
+          </p:cNvCxnSpPr>
+          <p:nvPr/>
+        </p:nvCxnSpPr>
+        <p:spPr>
+          <a:xfrm>
+            <a:off x="3644719" y="5474520"/>
+            <a:ext cx="0" cy="552607"/>
+          </a:xfrm>
+          <a:prstGeom prst="line">
+            <a:avLst/>
+          </a:prstGeom>
+          <a:ln>
+            <a:solidFill>
+              <a:srgbClr val="FF0000"/>
+            </a:solidFill>
+          </a:ln>
+        </p:spPr>
+        <p:style>
+          <a:lnRef idx="2">
+            <a:schemeClr val="accent1"/>
+          </a:lnRef>
+          <a:fillRef idx="0">
+            <a:schemeClr val="accent1"/>
+          </a:fillRef>
+          <a:effectRef idx="1">
+            <a:schemeClr val="accent1"/>
+          </a:effectRef>
+          <a:fontRef idx="minor">
+            <a:schemeClr val="tx1"/>
+          </a:fontRef>
+        </p:style>
+      </p:cxnSp>
+      <p:cxnSp>
+        <p:nvCxnSpPr>
+          <p:cNvPr id="25" name="Straight Connector 24">
+            <a:extLst>
+              <a:ext uri="{FF2B5EF4-FFF2-40B4-BE49-F238E27FC236}">
+                <a16:creationId xmlns:a16="http://schemas.microsoft.com/office/drawing/2014/main" id="{0A08EE9B-64CA-1884-9C65-F6A910B1109D}"/>
+              </a:ext>
+            </a:extLst>
+          </p:cNvPr>
+          <p:cNvCxnSpPr/>
+          <p:nvPr/>
+        </p:nvCxnSpPr>
+        <p:spPr>
+          <a:xfrm>
+            <a:off x="3345545" y="6148336"/>
+            <a:ext cx="576242" cy="0"/>
+          </a:xfrm>
+          <a:prstGeom prst="line">
+            <a:avLst/>
+          </a:prstGeom>
+          <a:ln>
+            <a:solidFill>
+              <a:schemeClr val="tx1"/>
+            </a:solidFill>
+          </a:ln>
+        </p:spPr>
+        <p:style>
+          <a:lnRef idx="2">
+            <a:schemeClr val="accent1"/>
+          </a:lnRef>
+          <a:fillRef idx="0">
+            <a:schemeClr val="accent1"/>
+          </a:fillRef>
+          <a:effectRef idx="1">
+            <a:schemeClr val="accent1"/>
+          </a:effectRef>
+          <a:fontRef idx="minor">
+            <a:schemeClr val="tx1"/>
+          </a:fontRef>
+        </p:style>
+      </p:cxnSp>
+      <p:cxnSp>
+        <p:nvCxnSpPr>
+          <p:cNvPr id="26" name="Straight Connector 25">
+            <a:extLst>
+              <a:ext uri="{FF2B5EF4-FFF2-40B4-BE49-F238E27FC236}">
+                <a16:creationId xmlns:a16="http://schemas.microsoft.com/office/drawing/2014/main" id="{8C5C2466-7C1E-372F-7908-7CE72D95DCEE}"/>
+              </a:ext>
+            </a:extLst>
+          </p:cNvPr>
+          <p:cNvCxnSpPr>
+            <a:cxnSpLocks/>
+          </p:cNvCxnSpPr>
+          <p:nvPr/>
+        </p:nvCxnSpPr>
+        <p:spPr>
+          <a:xfrm>
+            <a:off x="3921787" y="5521010"/>
+            <a:ext cx="0" cy="627326"/>
+          </a:xfrm>
+          <a:prstGeom prst="line">
+            <a:avLst/>
+          </a:prstGeom>
+          <a:ln>
+            <a:solidFill>
+              <a:schemeClr val="tx1"/>
+            </a:solidFill>
+          </a:ln>
+        </p:spPr>
+        <p:style>
+          <a:lnRef idx="2">
+            <a:schemeClr val="accent1"/>
+          </a:lnRef>
+          <a:fillRef idx="0">
+            <a:schemeClr val="accent1"/>
+          </a:fillRef>
+          <a:effectRef idx="1">
+            <a:schemeClr val="accent1"/>
+          </a:effectRef>
+          <a:fontRef idx="minor">
+            <a:schemeClr val="tx1"/>
+          </a:fontRef>
+        </p:style>
+      </p:cxnSp>
+      <p:cxnSp>
+        <p:nvCxnSpPr>
+          <p:cNvPr id="38" name="Straight Connector 37">
+            <a:extLst>
+              <a:ext uri="{FF2B5EF4-FFF2-40B4-BE49-F238E27FC236}">
+                <a16:creationId xmlns:a16="http://schemas.microsoft.com/office/drawing/2014/main" id="{6D0E06BD-2287-3C41-9FE2-1DFC5E8F21F6}"/>
+              </a:ext>
+            </a:extLst>
+          </p:cNvPr>
+          <p:cNvCxnSpPr/>
+          <p:nvPr/>
+        </p:nvCxnSpPr>
+        <p:spPr>
+          <a:xfrm>
+            <a:off x="3408954" y="4053169"/>
+            <a:ext cx="576242" cy="0"/>
+          </a:xfrm>
+          <a:prstGeom prst="line">
+            <a:avLst/>
+          </a:prstGeom>
+          <a:ln>
+            <a:solidFill>
+              <a:schemeClr val="accent3">
+                <a:lumMod val="60000"/>
+                <a:lumOff val="40000"/>
+              </a:schemeClr>
+            </a:solidFill>
+          </a:ln>
+        </p:spPr>
+        <p:style>
+          <a:lnRef idx="2">
+            <a:schemeClr val="accent1"/>
+          </a:lnRef>
+          <a:fillRef idx="0">
+            <a:schemeClr val="accent1"/>
+          </a:fillRef>
+          <a:effectRef idx="1">
+            <a:schemeClr val="accent1"/>
+          </a:effectRef>
+          <a:fontRef idx="minor">
+            <a:schemeClr val="tx1"/>
+          </a:fontRef>
+        </p:style>
+      </p:cxnSp>
+      <p:cxnSp>
+        <p:nvCxnSpPr>
+          <p:cNvPr id="39" name="Straight Connector 38">
+            <a:extLst>
+              <a:ext uri="{FF2B5EF4-FFF2-40B4-BE49-F238E27FC236}">
+                <a16:creationId xmlns:a16="http://schemas.microsoft.com/office/drawing/2014/main" id="{468884CE-5A48-11FF-8437-1F32282DF95D}"/>
+              </a:ext>
+            </a:extLst>
+          </p:cNvPr>
+          <p:cNvCxnSpPr>
+            <a:cxnSpLocks/>
+          </p:cNvCxnSpPr>
+          <p:nvPr/>
+        </p:nvCxnSpPr>
+        <p:spPr>
+          <a:xfrm>
+            <a:off x="3408954" y="4056900"/>
+            <a:ext cx="0" cy="627326"/>
+          </a:xfrm>
+          <a:prstGeom prst="line">
+            <a:avLst/>
+          </a:prstGeom>
+          <a:ln>
+            <a:solidFill>
+              <a:schemeClr val="accent3">
+                <a:lumMod val="60000"/>
+                <a:lumOff val="40000"/>
+              </a:schemeClr>
+            </a:solidFill>
+          </a:ln>
+        </p:spPr>
+        <p:style>
+          <a:lnRef idx="2">
+            <a:schemeClr val="accent1"/>
+          </a:lnRef>
+          <a:fillRef idx="0">
+            <a:schemeClr val="accent1"/>
+          </a:fillRef>
+          <a:effectRef idx="1">
+            <a:schemeClr val="accent1"/>
+          </a:effectRef>
+          <a:fontRef idx="minor">
+            <a:schemeClr val="tx1"/>
+          </a:fontRef>
+        </p:style>
+      </p:cxnSp>
+      <p:cxnSp>
+        <p:nvCxnSpPr>
+          <p:cNvPr id="41" name="Straight Connector 40">
+            <a:extLst>
+              <a:ext uri="{FF2B5EF4-FFF2-40B4-BE49-F238E27FC236}">
+                <a16:creationId xmlns:a16="http://schemas.microsoft.com/office/drawing/2014/main" id="{59B5EB29-4C5A-59B0-9EAB-3FAED52A22B9}"/>
+              </a:ext>
+            </a:extLst>
+          </p:cNvPr>
+          <p:cNvCxnSpPr/>
+          <p:nvPr/>
+        </p:nvCxnSpPr>
+        <p:spPr>
+          <a:xfrm>
+            <a:off x="3644719" y="4243669"/>
+            <a:ext cx="576242" cy="0"/>
+          </a:xfrm>
+          <a:prstGeom prst="line">
+            <a:avLst/>
+          </a:prstGeom>
+          <a:ln>
+            <a:solidFill>
+              <a:srgbClr val="FF0000"/>
+            </a:solidFill>
+          </a:ln>
+        </p:spPr>
+        <p:style>
+          <a:lnRef idx="2">
+            <a:schemeClr val="accent1"/>
+          </a:lnRef>
+          <a:fillRef idx="0">
+            <a:schemeClr val="accent1"/>
+          </a:fillRef>
+          <a:effectRef idx="1">
+            <a:schemeClr val="accent1"/>
+          </a:effectRef>
+          <a:fontRef idx="minor">
+            <a:schemeClr val="tx1"/>
+          </a:fontRef>
+        </p:style>
+      </p:cxnSp>
+      <p:cxnSp>
+        <p:nvCxnSpPr>
+          <p:cNvPr id="42" name="Straight Connector 41">
+            <a:extLst>
+              <a:ext uri="{FF2B5EF4-FFF2-40B4-BE49-F238E27FC236}">
+                <a16:creationId xmlns:a16="http://schemas.microsoft.com/office/drawing/2014/main" id="{C18333E4-81D6-5133-43C2-DD0E5FD9DB74}"/>
+              </a:ext>
+            </a:extLst>
+          </p:cNvPr>
+          <p:cNvCxnSpPr>
+            <a:cxnSpLocks/>
+          </p:cNvCxnSpPr>
+          <p:nvPr/>
+        </p:nvCxnSpPr>
+        <p:spPr>
+          <a:xfrm>
+            <a:off x="3644719" y="4247400"/>
+            <a:ext cx="0" cy="436826"/>
+          </a:xfrm>
+          <a:prstGeom prst="line">
+            <a:avLst/>
+          </a:prstGeom>
+          <a:ln>
+            <a:solidFill>
+              <a:srgbClr val="FF0000"/>
+            </a:solidFill>
+          </a:ln>
+        </p:spPr>
+        <p:style>
+          <a:lnRef idx="2">
+            <a:schemeClr val="accent1"/>
+          </a:lnRef>
+          <a:fillRef idx="0">
+            <a:schemeClr val="accent1"/>
+          </a:fillRef>
+          <a:effectRef idx="1">
+            <a:schemeClr val="accent1"/>
+          </a:effectRef>
+          <a:fontRef idx="minor">
+            <a:schemeClr val="tx1"/>
+          </a:fontRef>
+        </p:style>
+      </p:cxnSp>
+      <p:cxnSp>
+        <p:nvCxnSpPr>
+          <p:cNvPr id="43" name="Straight Connector 42">
+            <a:extLst>
+              <a:ext uri="{FF2B5EF4-FFF2-40B4-BE49-F238E27FC236}">
+                <a16:creationId xmlns:a16="http://schemas.microsoft.com/office/drawing/2014/main" id="{668D2B37-464F-3180-A671-FA7ABDBCEC34}"/>
+              </a:ext>
+            </a:extLst>
+          </p:cNvPr>
+          <p:cNvCxnSpPr/>
+          <p:nvPr/>
+        </p:nvCxnSpPr>
+        <p:spPr>
+          <a:xfrm>
+            <a:off x="3921787" y="4457982"/>
+            <a:ext cx="576242" cy="0"/>
+          </a:xfrm>
+          <a:prstGeom prst="line">
+            <a:avLst/>
+          </a:prstGeom>
+          <a:ln>
+            <a:solidFill>
+              <a:schemeClr val="tx1"/>
+            </a:solidFill>
+          </a:ln>
+        </p:spPr>
+        <p:style>
+          <a:lnRef idx="2">
+            <a:schemeClr val="accent1"/>
+          </a:lnRef>
+          <a:fillRef idx="0">
+            <a:schemeClr val="accent1"/>
+          </a:fillRef>
+          <a:effectRef idx="1">
+            <a:schemeClr val="accent1"/>
+          </a:effectRef>
+          <a:fontRef idx="minor">
+            <a:schemeClr val="tx1"/>
+          </a:fontRef>
+        </p:style>
+      </p:cxnSp>
+      <p:cxnSp>
+        <p:nvCxnSpPr>
+          <p:cNvPr id="44" name="Straight Connector 43">
+            <a:extLst>
+              <a:ext uri="{FF2B5EF4-FFF2-40B4-BE49-F238E27FC236}">
+                <a16:creationId xmlns:a16="http://schemas.microsoft.com/office/drawing/2014/main" id="{5CF543FA-73CD-26E6-4C08-72E49AC014F0}"/>
+              </a:ext>
+            </a:extLst>
+          </p:cNvPr>
+          <p:cNvCxnSpPr>
+            <a:cxnSpLocks/>
+          </p:cNvCxnSpPr>
+          <p:nvPr/>
+        </p:nvCxnSpPr>
+        <p:spPr>
+          <a:xfrm>
+            <a:off x="3921787" y="4461713"/>
+            <a:ext cx="0" cy="222513"/>
+          </a:xfrm>
+          <a:prstGeom prst="line">
+            <a:avLst/>
+          </a:prstGeom>
+          <a:ln>
+            <a:solidFill>
+              <a:schemeClr val="tx1"/>
+            </a:solidFill>
+          </a:ln>
+        </p:spPr>
+        <p:style>
+          <a:lnRef idx="2">
+            <a:schemeClr val="accent1"/>
+          </a:lnRef>
+          <a:fillRef idx="0">
+            <a:schemeClr val="accent1"/>
+          </a:fillRef>
+          <a:effectRef idx="1">
+            <a:schemeClr val="accent1"/>
+          </a:effectRef>
+          <a:fontRef idx="minor">
+            <a:schemeClr val="tx1"/>
+          </a:fontRef>
+        </p:style>
+      </p:cxnSp>
+      <p:sp>
+        <p:nvSpPr>
+          <p:cNvPr id="58" name="TextBox 57">
+            <a:extLst>
+              <a:ext uri="{FF2B5EF4-FFF2-40B4-BE49-F238E27FC236}">
+                <a16:creationId xmlns:a16="http://schemas.microsoft.com/office/drawing/2014/main" id="{C82E4CEA-E6E6-1387-EA6B-BC88FC987D14}"/>
+              </a:ext>
+            </a:extLst>
+          </p:cNvPr>
+          <p:cNvSpPr txBox="1"/>
+          <p:nvPr/>
+        </p:nvSpPr>
+        <p:spPr>
+          <a:xfrm>
+            <a:off x="2260546" y="5036304"/>
+            <a:ext cx="893956" cy="215444"/>
+          </a:xfrm>
+          <a:prstGeom prst="rect">
+            <a:avLst/>
+          </a:prstGeom>
+          <a:noFill/>
+        </p:spPr>
+        <p:txBody>
+          <a:bodyPr wrap="square" rtlCol="0">
+            <a:spAutoFit/>
+          </a:bodyPr>
+          <a:lstStyle/>
+          <a:p>
+            <a:r>
+              <a:rPr lang="en-US" sz="800" dirty="0"/>
+              <a:t>Note: Jumpers</a:t>
+            </a:r>
+          </a:p>
+        </p:txBody>
+      </p:sp>
+      <p:sp>
+        <p:nvSpPr>
+          <p:cNvPr id="59" name="Arrow: Right 58">
+            <a:extLst>
+              <a:ext uri="{FF2B5EF4-FFF2-40B4-BE49-F238E27FC236}">
+                <a16:creationId xmlns:a16="http://schemas.microsoft.com/office/drawing/2014/main" id="{9ECDAA60-97E5-8251-10F9-765BFB2E8B33}"/>
+              </a:ext>
+            </a:extLst>
+          </p:cNvPr>
+          <p:cNvSpPr/>
+          <p:nvPr/>
+        </p:nvSpPr>
+        <p:spPr>
+          <a:xfrm>
+            <a:off x="3035627" y="5042766"/>
+            <a:ext cx="288121" cy="231729"/>
+          </a:xfrm>
+          <a:prstGeom prst="rightArrow">
+            <a:avLst/>
+          </a:prstGeom>
+        </p:spPr>
+        <p:style>
+          <a:lnRef idx="2">
+            <a:schemeClr val="accent1">
+              <a:shade val="15000"/>
+            </a:schemeClr>
+          </a:lnRef>
+          <a:fillRef idx="1">
+            <a:schemeClr val="accent1"/>
+          </a:fillRef>
+          <a:effectRef idx="0">
+            <a:schemeClr val="accent1"/>
+          </a:effectRef>
+          <a:fontRef idx="minor">
+            <a:schemeClr val="lt1"/>
+          </a:fontRef>
+        </p:style>
+        <p:txBody>
+          <a:bodyPr rtlCol="0" anchor="ctr"/>
+          <a:lstStyle/>
+          <a:p>
+            <a:pPr algn="ctr"/>
+            <a:endParaRPr lang="en-US"/>
+          </a:p>
+        </p:txBody>
+      </p:sp>
+      <p:sp>
+        <p:nvSpPr>
+          <p:cNvPr id="61" name="TextBox 60">
+            <a:extLst>
+              <a:ext uri="{FF2B5EF4-FFF2-40B4-BE49-F238E27FC236}">
+                <a16:creationId xmlns:a16="http://schemas.microsoft.com/office/drawing/2014/main" id="{4250A276-2784-D286-576E-202C01A2CF0E}"/>
+              </a:ext>
+            </a:extLst>
+          </p:cNvPr>
+          <p:cNvSpPr txBox="1"/>
+          <p:nvPr/>
+        </p:nvSpPr>
+        <p:spPr>
+          <a:xfrm>
+            <a:off x="3921786" y="3920134"/>
+            <a:ext cx="576243" cy="215444"/>
+          </a:xfrm>
+          <a:prstGeom prst="rect">
+            <a:avLst/>
+          </a:prstGeom>
+          <a:noFill/>
+        </p:spPr>
+        <p:txBody>
+          <a:bodyPr wrap="square" rtlCol="0">
+            <a:spAutoFit/>
+          </a:bodyPr>
+          <a:lstStyle/>
+          <a:p>
+            <a:r>
+              <a:rPr lang="en-US" sz="800" dirty="0"/>
+              <a:t>G3</a:t>
+            </a:r>
+          </a:p>
+        </p:txBody>
+      </p:sp>
+      <p:sp>
+        <p:nvSpPr>
+          <p:cNvPr id="65" name="TextBox 64">
+            <a:extLst>
+              <a:ext uri="{FF2B5EF4-FFF2-40B4-BE49-F238E27FC236}">
+                <a16:creationId xmlns:a16="http://schemas.microsoft.com/office/drawing/2014/main" id="{554B5092-C3AA-C2B9-82BE-D1792FACF600}"/>
+              </a:ext>
+            </a:extLst>
+          </p:cNvPr>
+          <p:cNvSpPr txBox="1"/>
+          <p:nvPr/>
+        </p:nvSpPr>
+        <p:spPr>
+          <a:xfrm>
+            <a:off x="4157549" y="4121813"/>
+            <a:ext cx="576243" cy="215444"/>
+          </a:xfrm>
+          <a:prstGeom prst="rect">
+            <a:avLst/>
+          </a:prstGeom>
+          <a:noFill/>
+        </p:spPr>
+        <p:txBody>
+          <a:bodyPr wrap="square" rtlCol="0">
+            <a:spAutoFit/>
+          </a:bodyPr>
+          <a:lstStyle/>
+          <a:p>
+            <a:r>
+              <a:rPr lang="en-US" sz="800" dirty="0"/>
+              <a:t>N3</a:t>
+            </a:r>
+          </a:p>
+        </p:txBody>
+      </p:sp>
+      <p:sp>
+        <p:nvSpPr>
+          <p:cNvPr id="69" name="TextBox 68">
+            <a:extLst>
+              <a:ext uri="{FF2B5EF4-FFF2-40B4-BE49-F238E27FC236}">
+                <a16:creationId xmlns:a16="http://schemas.microsoft.com/office/drawing/2014/main" id="{9042742F-5792-404C-44D2-E5E104973449}"/>
+              </a:ext>
+            </a:extLst>
+          </p:cNvPr>
+          <p:cNvSpPr txBox="1"/>
+          <p:nvPr/>
+        </p:nvSpPr>
+        <p:spPr>
+          <a:xfrm>
+            <a:off x="4432683" y="4335053"/>
+            <a:ext cx="576243" cy="215444"/>
+          </a:xfrm>
+          <a:prstGeom prst="rect">
+            <a:avLst/>
+          </a:prstGeom>
+          <a:noFill/>
+        </p:spPr>
+        <p:txBody>
+          <a:bodyPr wrap="square" rtlCol="0">
+            <a:spAutoFit/>
+          </a:bodyPr>
+          <a:lstStyle/>
+          <a:p>
+            <a:r>
+              <a:rPr lang="en-US" sz="800" dirty="0"/>
+              <a:t>L3</a:t>
+            </a:r>
+          </a:p>
+        </p:txBody>
+      </p:sp>
+      <p:sp>
+        <p:nvSpPr>
+          <p:cNvPr id="93" name="TextBox 92">
+            <a:extLst>
+              <a:ext uri="{FF2B5EF4-FFF2-40B4-BE49-F238E27FC236}">
+                <a16:creationId xmlns:a16="http://schemas.microsoft.com/office/drawing/2014/main" id="{A86E6540-BFC5-B464-9CDA-A3B8BC10E9F2}"/>
+              </a:ext>
+            </a:extLst>
+          </p:cNvPr>
+          <p:cNvSpPr txBox="1"/>
+          <p:nvPr/>
+        </p:nvSpPr>
+        <p:spPr>
+          <a:xfrm>
+            <a:off x="5792113" y="3830401"/>
+            <a:ext cx="532414" cy="215444"/>
+          </a:xfrm>
+          <a:prstGeom prst="rect">
+            <a:avLst/>
+          </a:prstGeom>
+          <a:noFill/>
+        </p:spPr>
+        <p:txBody>
+          <a:bodyPr wrap="square" rtlCol="0">
+            <a:spAutoFit/>
+          </a:bodyPr>
+          <a:lstStyle/>
+          <a:p>
+            <a:r>
+              <a:rPr lang="en-US" sz="800" dirty="0"/>
+              <a:t>+V -V</a:t>
+            </a:r>
+          </a:p>
+        </p:txBody>
+      </p:sp>
+      <p:sp>
+        <p:nvSpPr>
+          <p:cNvPr id="107" name="TextBox 106">
+            <a:extLst>
+              <a:ext uri="{FF2B5EF4-FFF2-40B4-BE49-F238E27FC236}">
+                <a16:creationId xmlns:a16="http://schemas.microsoft.com/office/drawing/2014/main" id="{E0E0CB32-30A1-57D8-6766-DEBD7654DF01}"/>
+              </a:ext>
+            </a:extLst>
+          </p:cNvPr>
+          <p:cNvSpPr txBox="1"/>
+          <p:nvPr/>
+        </p:nvSpPr>
+        <p:spPr>
+          <a:xfrm>
+            <a:off x="9084359" y="1197826"/>
+            <a:ext cx="858698" cy="461665"/>
+          </a:xfrm>
+          <a:prstGeom prst="rect">
+            <a:avLst/>
+          </a:prstGeom>
+          <a:noFill/>
+        </p:spPr>
+        <p:txBody>
+          <a:bodyPr wrap="square" rtlCol="0">
+            <a:spAutoFit/>
+          </a:bodyPr>
+          <a:lstStyle/>
+          <a:p>
+            <a:r>
+              <a:rPr lang="en-US" sz="800" dirty="0"/>
+              <a:t>Red Light</a:t>
+            </a:r>
+          </a:p>
+          <a:p>
+            <a:endParaRPr lang="en-US" sz="800" dirty="0"/>
+          </a:p>
+          <a:p>
+            <a:r>
+              <a:rPr lang="en-US" sz="800" dirty="0"/>
+              <a:t>Green Light</a:t>
+            </a:r>
+          </a:p>
+        </p:txBody>
+      </p:sp>
+      <p:cxnSp>
+        <p:nvCxnSpPr>
+          <p:cNvPr id="135" name="Straight Connector 134">
+            <a:extLst>
+              <a:ext uri="{FF2B5EF4-FFF2-40B4-BE49-F238E27FC236}">
+                <a16:creationId xmlns:a16="http://schemas.microsoft.com/office/drawing/2014/main" id="{2B5FBB9F-2307-7889-951C-665FA269ABCF}"/>
+              </a:ext>
+            </a:extLst>
+          </p:cNvPr>
+          <p:cNvCxnSpPr>
+            <a:cxnSpLocks/>
+          </p:cNvCxnSpPr>
+          <p:nvPr/>
+        </p:nvCxnSpPr>
+        <p:spPr>
+          <a:xfrm>
+            <a:off x="9390536" y="1635382"/>
+            <a:ext cx="381550" cy="0"/>
+          </a:xfrm>
+          <a:prstGeom prst="line">
+            <a:avLst/>
+          </a:prstGeom>
+          <a:ln>
+            <a:solidFill>
+              <a:schemeClr val="tx2">
+                <a:lumMod val="75000"/>
+                <a:lumOff val="25000"/>
+              </a:schemeClr>
+            </a:solidFill>
+          </a:ln>
+        </p:spPr>
+        <p:style>
+          <a:lnRef idx="2">
+            <a:schemeClr val="accent1"/>
+          </a:lnRef>
+          <a:fillRef idx="0">
+            <a:schemeClr val="accent1"/>
+          </a:fillRef>
+          <a:effectRef idx="1">
+            <a:schemeClr val="accent1"/>
+          </a:effectRef>
+          <a:fontRef idx="minor">
+            <a:schemeClr val="tx1"/>
+          </a:fontRef>
+        </p:style>
+      </p:cxnSp>
+      <p:cxnSp>
+        <p:nvCxnSpPr>
+          <p:cNvPr id="136" name="Straight Connector 135">
+            <a:extLst>
+              <a:ext uri="{FF2B5EF4-FFF2-40B4-BE49-F238E27FC236}">
+                <a16:creationId xmlns:a16="http://schemas.microsoft.com/office/drawing/2014/main" id="{51BEE2BF-9D01-543B-3279-07D2078BFFCD}"/>
+              </a:ext>
+            </a:extLst>
+          </p:cNvPr>
+          <p:cNvCxnSpPr>
+            <a:cxnSpLocks/>
+          </p:cNvCxnSpPr>
+          <p:nvPr/>
+        </p:nvCxnSpPr>
+        <p:spPr>
+          <a:xfrm>
+            <a:off x="9772086" y="1635382"/>
+            <a:ext cx="0" cy="219292"/>
+          </a:xfrm>
+          <a:prstGeom prst="line">
+            <a:avLst/>
+          </a:prstGeom>
+          <a:ln>
+            <a:solidFill>
+              <a:schemeClr val="tx2">
+                <a:lumMod val="75000"/>
+                <a:lumOff val="25000"/>
+              </a:schemeClr>
+            </a:solidFill>
+          </a:ln>
+        </p:spPr>
+        <p:style>
+          <a:lnRef idx="2">
+            <a:schemeClr val="accent1"/>
+          </a:lnRef>
+          <a:fillRef idx="0">
+            <a:schemeClr val="accent1"/>
+          </a:fillRef>
+          <a:effectRef idx="1">
+            <a:schemeClr val="accent1"/>
+          </a:effectRef>
+          <a:fontRef idx="minor">
+            <a:schemeClr val="tx1"/>
+          </a:fontRef>
+        </p:style>
+      </p:cxnSp>
+      <p:cxnSp>
+        <p:nvCxnSpPr>
+          <p:cNvPr id="145" name="Straight Connector 144">
+            <a:extLst>
+              <a:ext uri="{FF2B5EF4-FFF2-40B4-BE49-F238E27FC236}">
+                <a16:creationId xmlns:a16="http://schemas.microsoft.com/office/drawing/2014/main" id="{8AE2F330-5E67-1908-C71A-F4F49F342F0B}"/>
+              </a:ext>
+            </a:extLst>
+          </p:cNvPr>
+          <p:cNvCxnSpPr>
+            <a:cxnSpLocks/>
+          </p:cNvCxnSpPr>
+          <p:nvPr/>
+        </p:nvCxnSpPr>
+        <p:spPr>
+          <a:xfrm flipV="1">
+            <a:off x="9390536" y="1396122"/>
+            <a:ext cx="645117" cy="5275"/>
+          </a:xfrm>
+          <a:prstGeom prst="line">
+            <a:avLst/>
+          </a:prstGeom>
+          <a:ln>
+            <a:solidFill>
+              <a:srgbClr val="FF0000"/>
+            </a:solidFill>
+          </a:ln>
+        </p:spPr>
+        <p:style>
+          <a:lnRef idx="2">
+            <a:schemeClr val="accent1"/>
+          </a:lnRef>
+          <a:fillRef idx="0">
+            <a:schemeClr val="accent1"/>
+          </a:fillRef>
+          <a:effectRef idx="1">
+            <a:schemeClr val="accent1"/>
+          </a:effectRef>
+          <a:fontRef idx="minor">
+            <a:schemeClr val="tx1"/>
+          </a:fontRef>
+        </p:style>
+      </p:cxnSp>
+      <p:cxnSp>
+        <p:nvCxnSpPr>
+          <p:cNvPr id="146" name="Straight Connector 145">
+            <a:extLst>
+              <a:ext uri="{FF2B5EF4-FFF2-40B4-BE49-F238E27FC236}">
+                <a16:creationId xmlns:a16="http://schemas.microsoft.com/office/drawing/2014/main" id="{708EB478-B7B7-AD45-CDF6-B969532BEBA3}"/>
+              </a:ext>
+            </a:extLst>
+          </p:cNvPr>
+          <p:cNvCxnSpPr>
+            <a:cxnSpLocks/>
+          </p:cNvCxnSpPr>
+          <p:nvPr/>
+        </p:nvCxnSpPr>
+        <p:spPr>
+          <a:xfrm>
+            <a:off x="10028160" y="1396122"/>
+            <a:ext cx="0" cy="367570"/>
+          </a:xfrm>
+          <a:prstGeom prst="line">
+            <a:avLst/>
+          </a:prstGeom>
+          <a:ln>
+            <a:solidFill>
+              <a:srgbClr val="FF0000"/>
+            </a:solidFill>
+          </a:ln>
+        </p:spPr>
+        <p:style>
+          <a:lnRef idx="2">
+            <a:schemeClr val="accent1"/>
+          </a:lnRef>
+          <a:fillRef idx="0">
+            <a:schemeClr val="accent1"/>
+          </a:fillRef>
+          <a:effectRef idx="1">
+            <a:schemeClr val="accent1"/>
+          </a:effectRef>
+          <a:fontRef idx="minor">
+            <a:schemeClr val="tx1"/>
+          </a:fontRef>
+        </p:style>
+      </p:cxnSp>
+      <p:cxnSp>
+        <p:nvCxnSpPr>
+          <p:cNvPr id="152" name="Straight Connector 151">
+            <a:extLst>
+              <a:ext uri="{FF2B5EF4-FFF2-40B4-BE49-F238E27FC236}">
+                <a16:creationId xmlns:a16="http://schemas.microsoft.com/office/drawing/2014/main" id="{D1EDBE72-4783-1F61-554E-983909CE5502}"/>
+              </a:ext>
+            </a:extLst>
+          </p:cNvPr>
+          <p:cNvCxnSpPr>
+            <a:cxnSpLocks/>
+          </p:cNvCxnSpPr>
+          <p:nvPr/>
+        </p:nvCxnSpPr>
+        <p:spPr>
+          <a:xfrm>
+            <a:off x="5257728" y="6336712"/>
+            <a:ext cx="501077" cy="0"/>
+          </a:xfrm>
+          <a:prstGeom prst="line">
+            <a:avLst/>
+          </a:prstGeom>
+          <a:ln>
+            <a:solidFill>
+              <a:schemeClr val="accent3">
+                <a:lumMod val="60000"/>
+                <a:lumOff val="40000"/>
+              </a:schemeClr>
+            </a:solidFill>
+          </a:ln>
+        </p:spPr>
+        <p:style>
+          <a:lnRef idx="2">
+            <a:schemeClr val="accent1"/>
+          </a:lnRef>
+          <a:fillRef idx="0">
+            <a:schemeClr val="accent1"/>
+          </a:fillRef>
+          <a:effectRef idx="1">
+            <a:schemeClr val="accent1"/>
+          </a:effectRef>
+          <a:fontRef idx="minor">
+            <a:schemeClr val="tx1"/>
+          </a:fontRef>
+        </p:style>
+      </p:cxnSp>
+      <p:cxnSp>
+        <p:nvCxnSpPr>
+          <p:cNvPr id="153" name="Straight Connector 152">
+            <a:extLst>
+              <a:ext uri="{FF2B5EF4-FFF2-40B4-BE49-F238E27FC236}">
+                <a16:creationId xmlns:a16="http://schemas.microsoft.com/office/drawing/2014/main" id="{196C9106-8DDF-AADA-5587-84D29123956B}"/>
+              </a:ext>
+            </a:extLst>
+          </p:cNvPr>
+          <p:cNvCxnSpPr>
+            <a:cxnSpLocks/>
+          </p:cNvCxnSpPr>
+          <p:nvPr/>
+        </p:nvCxnSpPr>
+        <p:spPr>
+          <a:xfrm>
+            <a:off x="5758805" y="6201299"/>
+            <a:ext cx="0" cy="135413"/>
+          </a:xfrm>
+          <a:prstGeom prst="line">
+            <a:avLst/>
+          </a:prstGeom>
+          <a:ln>
+            <a:solidFill>
+              <a:schemeClr val="accent3">
+                <a:lumMod val="60000"/>
+                <a:lumOff val="40000"/>
+              </a:schemeClr>
+            </a:solidFill>
+          </a:ln>
+        </p:spPr>
+        <p:style>
+          <a:lnRef idx="2">
+            <a:schemeClr val="accent1"/>
+          </a:lnRef>
+          <a:fillRef idx="0">
+            <a:schemeClr val="accent1"/>
+          </a:fillRef>
+          <a:effectRef idx="1">
+            <a:schemeClr val="accent1"/>
+          </a:effectRef>
+          <a:fontRef idx="minor">
+            <a:schemeClr val="tx1"/>
+          </a:fontRef>
+        </p:style>
+      </p:cxnSp>
+      <p:cxnSp>
+        <p:nvCxnSpPr>
+          <p:cNvPr id="155" name="Straight Connector 154">
+            <a:extLst>
+              <a:ext uri="{FF2B5EF4-FFF2-40B4-BE49-F238E27FC236}">
+                <a16:creationId xmlns:a16="http://schemas.microsoft.com/office/drawing/2014/main" id="{29538EB9-6833-F5DD-E030-4BB54D0BBF0E}"/>
+              </a:ext>
+            </a:extLst>
+          </p:cNvPr>
+          <p:cNvCxnSpPr>
+            <a:cxnSpLocks/>
+          </p:cNvCxnSpPr>
+          <p:nvPr/>
+        </p:nvCxnSpPr>
+        <p:spPr>
+          <a:xfrm>
+            <a:off x="5423448" y="6436725"/>
+            <a:ext cx="501077" cy="0"/>
+          </a:xfrm>
+          <a:prstGeom prst="line">
+            <a:avLst/>
+          </a:prstGeom>
+          <a:ln>
+            <a:solidFill>
+              <a:srgbClr val="FF0000"/>
+            </a:solidFill>
+          </a:ln>
+        </p:spPr>
+        <p:style>
+          <a:lnRef idx="2">
+            <a:schemeClr val="accent1"/>
+          </a:lnRef>
+          <a:fillRef idx="0">
+            <a:schemeClr val="accent1"/>
+          </a:fillRef>
+          <a:effectRef idx="1">
+            <a:schemeClr val="accent1"/>
+          </a:effectRef>
+          <a:fontRef idx="minor">
+            <a:schemeClr val="tx1"/>
+          </a:fontRef>
+        </p:style>
+      </p:cxnSp>
+      <p:cxnSp>
+        <p:nvCxnSpPr>
+          <p:cNvPr id="156" name="Straight Connector 155">
+            <a:extLst>
+              <a:ext uri="{FF2B5EF4-FFF2-40B4-BE49-F238E27FC236}">
+                <a16:creationId xmlns:a16="http://schemas.microsoft.com/office/drawing/2014/main" id="{7FE6F976-1FF1-969B-3B52-166235B86F46}"/>
+              </a:ext>
+            </a:extLst>
+          </p:cNvPr>
+          <p:cNvCxnSpPr>
+            <a:cxnSpLocks/>
+          </p:cNvCxnSpPr>
+          <p:nvPr/>
+        </p:nvCxnSpPr>
+        <p:spPr>
+          <a:xfrm>
+            <a:off x="5924525" y="6198244"/>
+            <a:ext cx="0" cy="238481"/>
+          </a:xfrm>
+          <a:prstGeom prst="line">
+            <a:avLst/>
+          </a:prstGeom>
+          <a:ln>
+            <a:solidFill>
+              <a:srgbClr val="FF0000"/>
+            </a:solidFill>
+          </a:ln>
+        </p:spPr>
+        <p:style>
+          <a:lnRef idx="2">
+            <a:schemeClr val="accent1"/>
+          </a:lnRef>
+          <a:fillRef idx="0">
+            <a:schemeClr val="accent1"/>
+          </a:fillRef>
+          <a:effectRef idx="1">
+            <a:schemeClr val="accent1"/>
+          </a:effectRef>
+          <a:fontRef idx="minor">
+            <a:schemeClr val="tx1"/>
+          </a:fontRef>
+        </p:style>
+      </p:cxnSp>
+      <p:cxnSp>
+        <p:nvCxnSpPr>
+          <p:cNvPr id="159" name="Straight Connector 158">
+            <a:extLst>
+              <a:ext uri="{FF2B5EF4-FFF2-40B4-BE49-F238E27FC236}">
+                <a16:creationId xmlns:a16="http://schemas.microsoft.com/office/drawing/2014/main" id="{A5AB3A36-AE02-C9C0-6CA7-3305C11BD172}"/>
+              </a:ext>
+            </a:extLst>
+          </p:cNvPr>
+          <p:cNvCxnSpPr>
+            <a:cxnSpLocks/>
+          </p:cNvCxnSpPr>
+          <p:nvPr/>
+        </p:nvCxnSpPr>
+        <p:spPr>
+          <a:xfrm>
+            <a:off x="5611456" y="6527212"/>
+            <a:ext cx="501077" cy="0"/>
+          </a:xfrm>
+          <a:prstGeom prst="line">
+            <a:avLst/>
+          </a:prstGeom>
+          <a:ln>
+            <a:solidFill>
+              <a:schemeClr val="tx1"/>
+            </a:solidFill>
+          </a:ln>
+        </p:spPr>
+        <p:style>
+          <a:lnRef idx="2">
+            <a:schemeClr val="accent1"/>
+          </a:lnRef>
+          <a:fillRef idx="0">
+            <a:schemeClr val="accent1"/>
+          </a:fillRef>
+          <a:effectRef idx="1">
+            <a:schemeClr val="accent1"/>
+          </a:effectRef>
+          <a:fontRef idx="minor">
+            <a:schemeClr val="tx1"/>
+          </a:fontRef>
+        </p:style>
+      </p:cxnSp>
+      <p:cxnSp>
+        <p:nvCxnSpPr>
+          <p:cNvPr id="160" name="Straight Connector 159">
+            <a:extLst>
+              <a:ext uri="{FF2B5EF4-FFF2-40B4-BE49-F238E27FC236}">
+                <a16:creationId xmlns:a16="http://schemas.microsoft.com/office/drawing/2014/main" id="{B7B3B55D-788F-7B86-D6DB-955FB83B01A5}"/>
+              </a:ext>
+            </a:extLst>
+          </p:cNvPr>
+          <p:cNvCxnSpPr>
+            <a:cxnSpLocks/>
+          </p:cNvCxnSpPr>
+          <p:nvPr/>
+        </p:nvCxnSpPr>
+        <p:spPr>
+          <a:xfrm>
+            <a:off x="6112533" y="6198244"/>
+            <a:ext cx="0" cy="328968"/>
+          </a:xfrm>
+          <a:prstGeom prst="line">
+            <a:avLst/>
+          </a:prstGeom>
+          <a:ln>
+            <a:solidFill>
+              <a:schemeClr val="tx1"/>
+            </a:solidFill>
+          </a:ln>
+        </p:spPr>
+        <p:style>
+          <a:lnRef idx="2">
+            <a:schemeClr val="accent1"/>
+          </a:lnRef>
+          <a:fillRef idx="0">
+            <a:schemeClr val="accent1"/>
+          </a:fillRef>
+          <a:effectRef idx="1">
+            <a:schemeClr val="accent1"/>
+          </a:effectRef>
+          <a:fontRef idx="minor">
+            <a:schemeClr val="tx1"/>
+          </a:fontRef>
+        </p:style>
+      </p:cxnSp>
+      <p:cxnSp>
+        <p:nvCxnSpPr>
+          <p:cNvPr id="201" name="Straight Connector 200">
+            <a:extLst>
+              <a:ext uri="{FF2B5EF4-FFF2-40B4-BE49-F238E27FC236}">
+                <a16:creationId xmlns:a16="http://schemas.microsoft.com/office/drawing/2014/main" id="{722CC749-143C-8DF9-6F4E-341FE4B51B67}"/>
+              </a:ext>
+            </a:extLst>
+          </p:cNvPr>
+          <p:cNvCxnSpPr>
+            <a:cxnSpLocks/>
+          </p:cNvCxnSpPr>
+          <p:nvPr/>
+        </p:nvCxnSpPr>
+        <p:spPr>
+          <a:xfrm>
+            <a:off x="5345249" y="3554032"/>
+            <a:ext cx="751615" cy="0"/>
+          </a:xfrm>
+          <a:prstGeom prst="line">
+            <a:avLst/>
+          </a:prstGeom>
+          <a:ln>
+            <a:solidFill>
+              <a:srgbClr val="FFC000"/>
+            </a:solidFill>
+          </a:ln>
+        </p:spPr>
+        <p:style>
+          <a:lnRef idx="2">
+            <a:schemeClr val="accent1"/>
+          </a:lnRef>
+          <a:fillRef idx="0">
+            <a:schemeClr val="accent1"/>
+          </a:fillRef>
+          <a:effectRef idx="1">
+            <a:schemeClr val="accent1"/>
+          </a:effectRef>
+          <a:fontRef idx="minor">
+            <a:schemeClr val="tx1"/>
+          </a:fontRef>
+        </p:style>
+      </p:cxnSp>
+      <p:cxnSp>
+        <p:nvCxnSpPr>
+          <p:cNvPr id="202" name="Straight Connector 201">
+            <a:extLst>
+              <a:ext uri="{FF2B5EF4-FFF2-40B4-BE49-F238E27FC236}">
+                <a16:creationId xmlns:a16="http://schemas.microsoft.com/office/drawing/2014/main" id="{4844F099-9393-71AF-77AD-76ECA1F2C65F}"/>
+              </a:ext>
+            </a:extLst>
+          </p:cNvPr>
+          <p:cNvCxnSpPr>
+            <a:cxnSpLocks/>
+          </p:cNvCxnSpPr>
+          <p:nvPr/>
+        </p:nvCxnSpPr>
+        <p:spPr>
+          <a:xfrm>
+            <a:off x="5887355" y="3689889"/>
+            <a:ext cx="0" cy="178944"/>
+          </a:xfrm>
+          <a:prstGeom prst="line">
+            <a:avLst/>
+          </a:prstGeom>
+          <a:ln>
+            <a:solidFill>
+              <a:srgbClr val="FF0000"/>
+            </a:solidFill>
+          </a:ln>
+        </p:spPr>
+        <p:style>
+          <a:lnRef idx="2">
+            <a:schemeClr val="accent1"/>
+          </a:lnRef>
+          <a:fillRef idx="0">
+            <a:schemeClr val="accent1"/>
+          </a:fillRef>
+          <a:effectRef idx="1">
+            <a:schemeClr val="accent1"/>
+          </a:effectRef>
+          <a:fontRef idx="minor">
+            <a:schemeClr val="tx1"/>
+          </a:fontRef>
+        </p:style>
+      </p:cxnSp>
+      <p:cxnSp>
+        <p:nvCxnSpPr>
+          <p:cNvPr id="203" name="Straight Connector 202">
+            <a:extLst>
+              <a:ext uri="{FF2B5EF4-FFF2-40B4-BE49-F238E27FC236}">
+                <a16:creationId xmlns:a16="http://schemas.microsoft.com/office/drawing/2014/main" id="{BF08F23F-880F-B194-210A-4ADFA5BE78EF}"/>
+              </a:ext>
+            </a:extLst>
+          </p:cNvPr>
+          <p:cNvCxnSpPr>
+            <a:cxnSpLocks/>
+          </p:cNvCxnSpPr>
+          <p:nvPr/>
+        </p:nvCxnSpPr>
+        <p:spPr>
+          <a:xfrm>
+            <a:off x="5345249" y="3689889"/>
+            <a:ext cx="532414" cy="0"/>
+          </a:xfrm>
+          <a:prstGeom prst="line">
+            <a:avLst/>
+          </a:prstGeom>
+          <a:ln>
+            <a:solidFill>
+              <a:srgbClr val="FF0000"/>
+            </a:solidFill>
+          </a:ln>
+        </p:spPr>
+        <p:style>
+          <a:lnRef idx="2">
+            <a:schemeClr val="accent1"/>
+          </a:lnRef>
+          <a:fillRef idx="0">
+            <a:schemeClr val="accent1"/>
+          </a:fillRef>
+          <a:effectRef idx="1">
+            <a:schemeClr val="accent1"/>
+          </a:effectRef>
+          <a:fontRef idx="minor">
+            <a:schemeClr val="tx1"/>
+          </a:fontRef>
+        </p:style>
+      </p:cxnSp>
+      <p:cxnSp>
+        <p:nvCxnSpPr>
+          <p:cNvPr id="204" name="Straight Connector 203">
+            <a:extLst>
+              <a:ext uri="{FF2B5EF4-FFF2-40B4-BE49-F238E27FC236}">
+                <a16:creationId xmlns:a16="http://schemas.microsoft.com/office/drawing/2014/main" id="{9EB70A55-7AEF-D3DE-7F6A-F85AA6A2C19B}"/>
+              </a:ext>
+            </a:extLst>
+          </p:cNvPr>
+          <p:cNvCxnSpPr>
+            <a:cxnSpLocks/>
+          </p:cNvCxnSpPr>
+          <p:nvPr/>
+        </p:nvCxnSpPr>
+        <p:spPr>
+          <a:xfrm>
+            <a:off x="6097241" y="3546454"/>
+            <a:ext cx="0" cy="322379"/>
+          </a:xfrm>
+          <a:prstGeom prst="line">
+            <a:avLst/>
+          </a:prstGeom>
+          <a:ln>
+            <a:solidFill>
+              <a:srgbClr val="FFC000"/>
+            </a:solidFill>
+          </a:ln>
+        </p:spPr>
+        <p:style>
+          <a:lnRef idx="2">
+            <a:schemeClr val="accent1"/>
+          </a:lnRef>
+          <a:fillRef idx="0">
+            <a:schemeClr val="accent1"/>
+          </a:fillRef>
+          <a:effectRef idx="1">
+            <a:schemeClr val="accent1"/>
+          </a:effectRef>
+          <a:fontRef idx="minor">
+            <a:schemeClr val="tx1"/>
+          </a:fontRef>
+        </p:style>
+      </p:cxnSp>
+      <p:pic>
+        <p:nvPicPr>
+          <p:cNvPr id="3" name="Picture 2">
+            <a:extLst>
+              <a:ext uri="{FF2B5EF4-FFF2-40B4-BE49-F238E27FC236}">
+                <a16:creationId xmlns:a16="http://schemas.microsoft.com/office/drawing/2014/main" id="{E4E8907B-776B-E4D9-9D0A-67F23A32EDEE}"/>
+              </a:ext>
+            </a:extLst>
+          </p:cNvPr>
+          <p:cNvPicPr>
+            <a:picLocks noChangeAspect="1"/>
+          </p:cNvPicPr>
+          <p:nvPr/>
+        </p:nvPicPr>
+        <p:blipFill>
+          <a:blip r:embed="rId3"/>
+          <a:stretch>
+            <a:fillRect/>
+          </a:stretch>
+        </p:blipFill>
+        <p:spPr>
+          <a:xfrm>
+            <a:off x="8111020" y="190604"/>
+            <a:ext cx="1000721" cy="1769347"/>
+          </a:xfrm>
+          <a:prstGeom prst="rect">
+            <a:avLst/>
+          </a:prstGeom>
+        </p:spPr>
+      </p:pic>
+      <p:pic>
+        <p:nvPicPr>
+          <p:cNvPr id="6" name="Picture 5">
+            <a:extLst>
+              <a:ext uri="{FF2B5EF4-FFF2-40B4-BE49-F238E27FC236}">
+                <a16:creationId xmlns:a16="http://schemas.microsoft.com/office/drawing/2014/main" id="{798B31CE-8F07-8546-7367-AD25E9A31C12}"/>
+              </a:ext>
+            </a:extLst>
+          </p:cNvPr>
+          <p:cNvPicPr>
+            <a:picLocks noChangeAspect="1"/>
+          </p:cNvPicPr>
+          <p:nvPr/>
+        </p:nvPicPr>
+        <p:blipFill>
+          <a:blip r:embed="rId4"/>
+          <a:stretch>
+            <a:fillRect/>
+          </a:stretch>
+        </p:blipFill>
+        <p:spPr>
+          <a:xfrm>
+            <a:off x="5756953" y="4033129"/>
+            <a:ext cx="471335" cy="1901879"/>
+          </a:xfrm>
+          <a:prstGeom prst="rect">
+            <a:avLst/>
+          </a:prstGeom>
+        </p:spPr>
+      </p:pic>
+      <p:pic>
+        <p:nvPicPr>
+          <p:cNvPr id="10" name="Picture 9">
+            <a:extLst>
+              <a:ext uri="{FF2B5EF4-FFF2-40B4-BE49-F238E27FC236}">
+                <a16:creationId xmlns:a16="http://schemas.microsoft.com/office/drawing/2014/main" id="{B1D4AB85-7354-870F-8E0B-BFE9CEF9BD09}"/>
+              </a:ext>
+            </a:extLst>
+          </p:cNvPr>
+          <p:cNvPicPr>
+            <a:picLocks noChangeAspect="1"/>
+          </p:cNvPicPr>
+          <p:nvPr/>
+        </p:nvPicPr>
+        <p:blipFill>
+          <a:blip r:embed="rId5"/>
+          <a:stretch>
+            <a:fillRect/>
+          </a:stretch>
+        </p:blipFill>
+        <p:spPr>
+          <a:xfrm>
+            <a:off x="3332141" y="4705896"/>
+            <a:ext cx="790632" cy="758825"/>
+          </a:xfrm>
+          <a:prstGeom prst="rect">
+            <a:avLst/>
+          </a:prstGeom>
+        </p:spPr>
+      </p:pic>
+      <p:sp>
+        <p:nvSpPr>
+          <p:cNvPr id="15" name="TextBox 14">
+            <a:extLst>
+              <a:ext uri="{FF2B5EF4-FFF2-40B4-BE49-F238E27FC236}">
+                <a16:creationId xmlns:a16="http://schemas.microsoft.com/office/drawing/2014/main" id="{32BD9A26-2CBA-27E6-768E-C2336B92387A}"/>
+              </a:ext>
+            </a:extLst>
+          </p:cNvPr>
+          <p:cNvSpPr txBox="1"/>
+          <p:nvPr/>
+        </p:nvSpPr>
+        <p:spPr>
+          <a:xfrm>
+            <a:off x="7489886" y="1197826"/>
+            <a:ext cx="858698" cy="584775"/>
+          </a:xfrm>
+          <a:prstGeom prst="rect">
+            <a:avLst/>
+          </a:prstGeom>
+          <a:noFill/>
+        </p:spPr>
+        <p:txBody>
+          <a:bodyPr wrap="square" rtlCol="0">
+            <a:spAutoFit/>
+          </a:bodyPr>
+          <a:lstStyle/>
+          <a:p>
+            <a:r>
+              <a:rPr lang="en-US" sz="800" dirty="0"/>
+              <a:t>Red Light</a:t>
+            </a:r>
+          </a:p>
+          <a:p>
+            <a:endParaRPr lang="en-US" sz="800" dirty="0"/>
+          </a:p>
+          <a:p>
+            <a:endParaRPr lang="en-US" sz="800" dirty="0"/>
+          </a:p>
+          <a:p>
+            <a:r>
+              <a:rPr lang="en-US" sz="800" dirty="0" err="1"/>
+              <a:t>eStop</a:t>
+            </a:r>
+            <a:endParaRPr lang="en-US" sz="800" dirty="0"/>
+          </a:p>
+        </p:txBody>
+      </p:sp>
+      <p:cxnSp>
+        <p:nvCxnSpPr>
+          <p:cNvPr id="16" name="Straight Connector 15">
+            <a:extLst>
+              <a:ext uri="{FF2B5EF4-FFF2-40B4-BE49-F238E27FC236}">
+                <a16:creationId xmlns:a16="http://schemas.microsoft.com/office/drawing/2014/main" id="{CE2DCD52-D321-AD21-39DC-E8742123C08B}"/>
+              </a:ext>
+            </a:extLst>
+          </p:cNvPr>
+          <p:cNvCxnSpPr>
+            <a:cxnSpLocks/>
+          </p:cNvCxnSpPr>
+          <p:nvPr/>
+        </p:nvCxnSpPr>
+        <p:spPr>
+          <a:xfrm>
+            <a:off x="7431465" y="1618450"/>
+            <a:ext cx="637268" cy="0"/>
+          </a:xfrm>
+          <a:prstGeom prst="line">
+            <a:avLst/>
+          </a:prstGeom>
+          <a:ln>
+            <a:solidFill>
+              <a:schemeClr val="accent3">
+                <a:lumMod val="60000"/>
+                <a:lumOff val="40000"/>
+              </a:schemeClr>
+            </a:solidFill>
+          </a:ln>
+        </p:spPr>
+        <p:style>
+          <a:lnRef idx="2">
+            <a:schemeClr val="accent1"/>
+          </a:lnRef>
+          <a:fillRef idx="0">
+            <a:schemeClr val="accent1"/>
+          </a:fillRef>
+          <a:effectRef idx="1">
+            <a:schemeClr val="accent1"/>
+          </a:effectRef>
+          <a:fontRef idx="minor">
+            <a:schemeClr val="tx1"/>
+          </a:fontRef>
+        </p:style>
+      </p:cxnSp>
+      <p:cxnSp>
+        <p:nvCxnSpPr>
+          <p:cNvPr id="18" name="Straight Connector 17">
+            <a:extLst>
+              <a:ext uri="{FF2B5EF4-FFF2-40B4-BE49-F238E27FC236}">
+                <a16:creationId xmlns:a16="http://schemas.microsoft.com/office/drawing/2014/main" id="{3C04E9CF-B15A-EF0B-BF90-F22A04A4F7DE}"/>
+              </a:ext>
+            </a:extLst>
+          </p:cNvPr>
+          <p:cNvCxnSpPr>
+            <a:cxnSpLocks/>
+          </p:cNvCxnSpPr>
+          <p:nvPr/>
+        </p:nvCxnSpPr>
+        <p:spPr>
+          <a:xfrm>
+            <a:off x="7419478" y="1618450"/>
+            <a:ext cx="0" cy="219292"/>
+          </a:xfrm>
+          <a:prstGeom prst="line">
+            <a:avLst/>
+          </a:prstGeom>
+          <a:ln>
+            <a:solidFill>
+              <a:schemeClr val="accent3">
+                <a:lumMod val="60000"/>
+                <a:lumOff val="40000"/>
+              </a:schemeClr>
+            </a:solidFill>
+          </a:ln>
+        </p:spPr>
+        <p:style>
+          <a:lnRef idx="2">
+            <a:schemeClr val="accent1"/>
+          </a:lnRef>
+          <a:fillRef idx="0">
+            <a:schemeClr val="accent1"/>
+          </a:fillRef>
+          <a:effectRef idx="1">
+            <a:schemeClr val="accent1"/>
+          </a:effectRef>
+          <a:fontRef idx="minor">
+            <a:schemeClr val="tx1"/>
+          </a:fontRef>
+        </p:style>
+      </p:cxnSp>
+      <p:cxnSp>
+        <p:nvCxnSpPr>
+          <p:cNvPr id="21" name="Straight Connector 20">
+            <a:extLst>
+              <a:ext uri="{FF2B5EF4-FFF2-40B4-BE49-F238E27FC236}">
+                <a16:creationId xmlns:a16="http://schemas.microsoft.com/office/drawing/2014/main" id="{D80A27C7-FFA2-7E70-4401-50BB4064AED1}"/>
+              </a:ext>
+            </a:extLst>
+          </p:cNvPr>
+          <p:cNvCxnSpPr>
+            <a:cxnSpLocks/>
+          </p:cNvCxnSpPr>
+          <p:nvPr/>
+        </p:nvCxnSpPr>
+        <p:spPr>
+          <a:xfrm flipV="1">
+            <a:off x="7275211" y="1396122"/>
+            <a:ext cx="645117" cy="5275"/>
+          </a:xfrm>
+          <a:prstGeom prst="line">
+            <a:avLst/>
+          </a:prstGeom>
+          <a:ln>
+            <a:solidFill>
+              <a:srgbClr val="FF0000"/>
+            </a:solidFill>
+          </a:ln>
+        </p:spPr>
+        <p:style>
+          <a:lnRef idx="2">
+            <a:schemeClr val="accent1"/>
+          </a:lnRef>
+          <a:fillRef idx="0">
+            <a:schemeClr val="accent1"/>
+          </a:fillRef>
+          <a:effectRef idx="1">
+            <a:schemeClr val="accent1"/>
+          </a:effectRef>
+          <a:fontRef idx="minor">
+            <a:schemeClr val="tx1"/>
+          </a:fontRef>
+        </p:style>
+      </p:cxnSp>
+      <p:cxnSp>
+        <p:nvCxnSpPr>
+          <p:cNvPr id="22" name="Straight Connector 21">
+            <a:extLst>
+              <a:ext uri="{FF2B5EF4-FFF2-40B4-BE49-F238E27FC236}">
+                <a16:creationId xmlns:a16="http://schemas.microsoft.com/office/drawing/2014/main" id="{566E5E03-E88D-44F5-DCD1-5633414A3E51}"/>
+              </a:ext>
+            </a:extLst>
+          </p:cNvPr>
+          <p:cNvCxnSpPr>
+            <a:cxnSpLocks/>
+          </p:cNvCxnSpPr>
+          <p:nvPr/>
+        </p:nvCxnSpPr>
+        <p:spPr>
+          <a:xfrm>
+            <a:off x="7276230" y="1396122"/>
+            <a:ext cx="0" cy="367570"/>
+          </a:xfrm>
+          <a:prstGeom prst="line">
+            <a:avLst/>
+          </a:prstGeom>
+          <a:ln>
+            <a:solidFill>
+              <a:srgbClr val="FF0000"/>
+            </a:solidFill>
+          </a:ln>
+        </p:spPr>
+        <p:style>
+          <a:lnRef idx="2">
+            <a:schemeClr val="accent1"/>
+          </a:lnRef>
+          <a:fillRef idx="0">
+            <a:schemeClr val="accent1"/>
+          </a:fillRef>
+          <a:effectRef idx="1">
+            <a:schemeClr val="accent1"/>
+          </a:effectRef>
+          <a:fontRef idx="minor">
+            <a:schemeClr val="tx1"/>
+          </a:fontRef>
+        </p:style>
+      </p:cxnSp>
+      <p:sp>
+        <p:nvSpPr>
+          <p:cNvPr id="29" name="TextBox 28">
+            <a:extLst>
+              <a:ext uri="{FF2B5EF4-FFF2-40B4-BE49-F238E27FC236}">
+                <a16:creationId xmlns:a16="http://schemas.microsoft.com/office/drawing/2014/main" id="{0BD99EF4-4D73-1115-EB07-57BA80F35EFF}"/>
+              </a:ext>
+            </a:extLst>
+          </p:cNvPr>
+          <p:cNvSpPr txBox="1"/>
+          <p:nvPr/>
+        </p:nvSpPr>
+        <p:spPr>
+          <a:xfrm>
+            <a:off x="3859547" y="2468838"/>
+            <a:ext cx="781951" cy="215444"/>
+          </a:xfrm>
+          <a:prstGeom prst="rect">
+            <a:avLst/>
+          </a:prstGeom>
+          <a:noFill/>
+        </p:spPr>
+        <p:txBody>
+          <a:bodyPr wrap="square" rtlCol="0">
+            <a:spAutoFit/>
+          </a:bodyPr>
+          <a:lstStyle/>
+          <a:p>
+            <a:r>
+              <a:rPr lang="en-US" sz="800" dirty="0"/>
+              <a:t>+V</a:t>
+            </a:r>
+          </a:p>
+        </p:txBody>
+      </p:sp>
+      <p:cxnSp>
+        <p:nvCxnSpPr>
+          <p:cNvPr id="32" name="Straight Connector 31">
+            <a:extLst>
+              <a:ext uri="{FF2B5EF4-FFF2-40B4-BE49-F238E27FC236}">
+                <a16:creationId xmlns:a16="http://schemas.microsoft.com/office/drawing/2014/main" id="{22CE0CE5-9D8D-406B-C0BC-990EB5E028D2}"/>
+              </a:ext>
+            </a:extLst>
+          </p:cNvPr>
+          <p:cNvCxnSpPr>
+            <a:cxnSpLocks/>
+          </p:cNvCxnSpPr>
+          <p:nvPr/>
+        </p:nvCxnSpPr>
+        <p:spPr>
+          <a:xfrm>
+            <a:off x="4035363" y="2289894"/>
+            <a:ext cx="0" cy="178944"/>
+          </a:xfrm>
+          <a:prstGeom prst="line">
+            <a:avLst/>
+          </a:prstGeom>
+          <a:ln>
+            <a:solidFill>
+              <a:srgbClr val="FF0000"/>
+            </a:solidFill>
+          </a:ln>
+        </p:spPr>
+        <p:style>
+          <a:lnRef idx="2">
+            <a:schemeClr val="accent1"/>
+          </a:lnRef>
+          <a:fillRef idx="0">
+            <a:schemeClr val="accent1"/>
+          </a:fillRef>
+          <a:effectRef idx="1">
+            <a:schemeClr val="accent1"/>
+          </a:effectRef>
+          <a:fontRef idx="minor">
+            <a:schemeClr val="tx1"/>
+          </a:fontRef>
+        </p:style>
+      </p:cxnSp>
+      <p:cxnSp>
+        <p:nvCxnSpPr>
+          <p:cNvPr id="37" name="Straight Connector 36">
+            <a:extLst>
+              <a:ext uri="{FF2B5EF4-FFF2-40B4-BE49-F238E27FC236}">
+                <a16:creationId xmlns:a16="http://schemas.microsoft.com/office/drawing/2014/main" id="{4B6DA2C6-5FE5-3C03-3961-AA6F789714F6}"/>
+              </a:ext>
+            </a:extLst>
+          </p:cNvPr>
+          <p:cNvCxnSpPr>
+            <a:cxnSpLocks/>
+          </p:cNvCxnSpPr>
+          <p:nvPr/>
+        </p:nvCxnSpPr>
+        <p:spPr>
+          <a:xfrm>
+            <a:off x="4273892" y="2289894"/>
+            <a:ext cx="0" cy="178944"/>
+          </a:xfrm>
+          <a:prstGeom prst="line">
+            <a:avLst/>
+          </a:prstGeom>
+          <a:ln>
+            <a:solidFill>
+              <a:schemeClr val="tx2">
+                <a:lumMod val="75000"/>
+                <a:lumOff val="25000"/>
+              </a:schemeClr>
+            </a:solidFill>
+          </a:ln>
+        </p:spPr>
+        <p:style>
+          <a:lnRef idx="2">
+            <a:schemeClr val="accent1"/>
+          </a:lnRef>
+          <a:fillRef idx="0">
+            <a:schemeClr val="accent1"/>
+          </a:fillRef>
+          <a:effectRef idx="1">
+            <a:schemeClr val="accent1"/>
+          </a:effectRef>
+          <a:fontRef idx="minor">
+            <a:schemeClr val="tx1"/>
+          </a:fontRef>
+        </p:style>
+      </p:cxnSp>
+      <p:cxnSp>
+        <p:nvCxnSpPr>
+          <p:cNvPr id="40" name="Straight Connector 39">
+            <a:extLst>
+              <a:ext uri="{FF2B5EF4-FFF2-40B4-BE49-F238E27FC236}">
+                <a16:creationId xmlns:a16="http://schemas.microsoft.com/office/drawing/2014/main" id="{59BE965C-50D3-1547-D826-941C08FD26E2}"/>
+              </a:ext>
+            </a:extLst>
+          </p:cNvPr>
+          <p:cNvCxnSpPr>
+            <a:cxnSpLocks/>
+          </p:cNvCxnSpPr>
+          <p:nvPr/>
+        </p:nvCxnSpPr>
+        <p:spPr>
+          <a:xfrm>
+            <a:off x="4148176" y="2289894"/>
+            <a:ext cx="0" cy="178944"/>
+          </a:xfrm>
+          <a:prstGeom prst="line">
+            <a:avLst/>
+          </a:prstGeom>
+          <a:ln>
+            <a:solidFill>
+              <a:srgbClr val="FFC000"/>
+            </a:solidFill>
+          </a:ln>
+        </p:spPr>
+        <p:style>
+          <a:lnRef idx="2">
+            <a:schemeClr val="accent1"/>
+          </a:lnRef>
+          <a:fillRef idx="0">
+            <a:schemeClr val="accent1"/>
+          </a:fillRef>
+          <a:effectRef idx="1">
+            <a:schemeClr val="accent1"/>
+          </a:effectRef>
+          <a:fontRef idx="minor">
+            <a:schemeClr val="tx1"/>
+          </a:fontRef>
+        </p:style>
+      </p:cxnSp>
+      <p:cxnSp>
+        <p:nvCxnSpPr>
+          <p:cNvPr id="45" name="Straight Connector 44">
+            <a:extLst>
+              <a:ext uri="{FF2B5EF4-FFF2-40B4-BE49-F238E27FC236}">
+                <a16:creationId xmlns:a16="http://schemas.microsoft.com/office/drawing/2014/main" id="{9DBA38E5-87A1-3F22-E1AA-0C3C9560FA03}"/>
+              </a:ext>
+            </a:extLst>
+          </p:cNvPr>
+          <p:cNvCxnSpPr>
+            <a:cxnSpLocks/>
+          </p:cNvCxnSpPr>
+          <p:nvPr/>
+        </p:nvCxnSpPr>
+        <p:spPr>
+          <a:xfrm>
+            <a:off x="4354743" y="2272583"/>
+            <a:ext cx="0" cy="196838"/>
+          </a:xfrm>
+          <a:prstGeom prst="line">
+            <a:avLst/>
+          </a:prstGeom>
+          <a:ln>
+            <a:solidFill>
+              <a:srgbClr val="FF0000"/>
+            </a:solidFill>
+          </a:ln>
+        </p:spPr>
+        <p:style>
+          <a:lnRef idx="2">
+            <a:schemeClr val="accent1"/>
+          </a:lnRef>
+          <a:fillRef idx="0">
+            <a:schemeClr val="accent1"/>
+          </a:fillRef>
+          <a:effectRef idx="1">
+            <a:schemeClr val="accent1"/>
+          </a:effectRef>
+          <a:fontRef idx="minor">
+            <a:schemeClr val="tx1"/>
+          </a:fontRef>
+        </p:style>
+      </p:cxnSp>
+      <p:cxnSp>
+        <p:nvCxnSpPr>
+          <p:cNvPr id="46" name="Straight Connector 45">
+            <a:extLst>
+              <a:ext uri="{FF2B5EF4-FFF2-40B4-BE49-F238E27FC236}">
+                <a16:creationId xmlns:a16="http://schemas.microsoft.com/office/drawing/2014/main" id="{338C9E46-1D30-7816-8AA0-B4970DF5AD13}"/>
+              </a:ext>
+            </a:extLst>
+          </p:cNvPr>
+          <p:cNvCxnSpPr>
+            <a:cxnSpLocks/>
+          </p:cNvCxnSpPr>
+          <p:nvPr/>
+        </p:nvCxnSpPr>
+        <p:spPr>
+          <a:xfrm>
+            <a:off x="4459722" y="2282435"/>
+            <a:ext cx="0" cy="178944"/>
+          </a:xfrm>
+          <a:prstGeom prst="line">
+            <a:avLst/>
+          </a:prstGeom>
+          <a:ln>
+            <a:solidFill>
+              <a:schemeClr val="accent3">
+                <a:lumMod val="60000"/>
+                <a:lumOff val="40000"/>
+              </a:schemeClr>
+            </a:solidFill>
+          </a:ln>
+        </p:spPr>
+        <p:style>
+          <a:lnRef idx="2">
+            <a:schemeClr val="accent1"/>
+          </a:lnRef>
+          <a:fillRef idx="0">
+            <a:schemeClr val="accent1"/>
+          </a:fillRef>
+          <a:effectRef idx="1">
+            <a:schemeClr val="accent1"/>
+          </a:effectRef>
+          <a:fontRef idx="minor">
+            <a:schemeClr val="tx1"/>
+          </a:fontRef>
+        </p:style>
+      </p:cxnSp>
+      <p:cxnSp>
+        <p:nvCxnSpPr>
+          <p:cNvPr id="53" name="Straight Connector 52">
+            <a:extLst>
+              <a:ext uri="{FF2B5EF4-FFF2-40B4-BE49-F238E27FC236}">
+                <a16:creationId xmlns:a16="http://schemas.microsoft.com/office/drawing/2014/main" id="{024BF81A-4465-669E-B452-3DF723B43F13}"/>
+              </a:ext>
+            </a:extLst>
+          </p:cNvPr>
+          <p:cNvCxnSpPr>
+            <a:cxnSpLocks/>
+          </p:cNvCxnSpPr>
+          <p:nvPr/>
+        </p:nvCxnSpPr>
+        <p:spPr>
+          <a:xfrm>
+            <a:off x="4550537" y="2277782"/>
+            <a:ext cx="0" cy="178944"/>
+          </a:xfrm>
+          <a:prstGeom prst="line">
+            <a:avLst/>
+          </a:prstGeom>
+          <a:ln>
+            <a:solidFill>
+              <a:schemeClr val="tx1"/>
+            </a:solidFill>
+          </a:ln>
+        </p:spPr>
+        <p:style>
+          <a:lnRef idx="2">
+            <a:schemeClr val="accent1"/>
+          </a:lnRef>
+          <a:fillRef idx="0">
+            <a:schemeClr val="accent1"/>
+          </a:fillRef>
+          <a:effectRef idx="1">
+            <a:schemeClr val="accent1"/>
+          </a:effectRef>
+          <a:fontRef idx="minor">
+            <a:schemeClr val="tx1"/>
+          </a:fontRef>
+        </p:style>
+      </p:cxnSp>
+      <p:sp>
+        <p:nvSpPr>
+          <p:cNvPr id="55" name="TextBox 54">
+            <a:extLst>
+              <a:ext uri="{FF2B5EF4-FFF2-40B4-BE49-F238E27FC236}">
+                <a16:creationId xmlns:a16="http://schemas.microsoft.com/office/drawing/2014/main" id="{40CF5920-30DA-CC0F-BB3F-27D6C8CD8CE3}"/>
+              </a:ext>
+            </a:extLst>
+          </p:cNvPr>
+          <p:cNvSpPr txBox="1"/>
+          <p:nvPr/>
+        </p:nvSpPr>
+        <p:spPr>
+          <a:xfrm rot="5400000">
+            <a:off x="3998531" y="2562797"/>
+            <a:ext cx="532272" cy="215444"/>
+          </a:xfrm>
+          <a:prstGeom prst="rect">
+            <a:avLst/>
+          </a:prstGeom>
+          <a:noFill/>
+        </p:spPr>
+        <p:txBody>
+          <a:bodyPr wrap="square" rtlCol="0">
+            <a:spAutoFit/>
+          </a:bodyPr>
+          <a:lstStyle/>
+          <a:p>
+            <a:r>
+              <a:rPr lang="en-US" sz="800" dirty="0"/>
+              <a:t>To FGR </a:t>
+            </a:r>
+          </a:p>
+        </p:txBody>
+      </p:sp>
+      <p:sp>
+        <p:nvSpPr>
+          <p:cNvPr id="57" name="TextBox 56">
+            <a:extLst>
+              <a:ext uri="{FF2B5EF4-FFF2-40B4-BE49-F238E27FC236}">
+                <a16:creationId xmlns:a16="http://schemas.microsoft.com/office/drawing/2014/main" id="{C98DAC81-B348-FE12-6B86-3A1C14074371}"/>
+              </a:ext>
+            </a:extLst>
+          </p:cNvPr>
+          <p:cNvSpPr txBox="1"/>
+          <p:nvPr/>
+        </p:nvSpPr>
+        <p:spPr>
+          <a:xfrm rot="5400000">
+            <a:off x="4090427" y="2553676"/>
+            <a:ext cx="532272" cy="236988"/>
+          </a:xfrm>
+          <a:prstGeom prst="rect">
+            <a:avLst/>
+          </a:prstGeom>
+          <a:noFill/>
+        </p:spPr>
+        <p:txBody>
+          <a:bodyPr wrap="square" rtlCol="0">
+            <a:spAutoFit/>
+          </a:bodyPr>
+          <a:lstStyle/>
+          <a:p>
+            <a:r>
+              <a:rPr lang="en-US" sz="800" dirty="0"/>
+              <a:t>To FGR </a:t>
+            </a:r>
+          </a:p>
+        </p:txBody>
+      </p:sp>
+      <p:sp>
+        <p:nvSpPr>
+          <p:cNvPr id="62" name="TextBox 61">
+            <a:extLst>
+              <a:ext uri="{FF2B5EF4-FFF2-40B4-BE49-F238E27FC236}">
+                <a16:creationId xmlns:a16="http://schemas.microsoft.com/office/drawing/2014/main" id="{DD7F888E-44B7-1501-BBE4-4CA1C18C78ED}"/>
+              </a:ext>
+            </a:extLst>
+          </p:cNvPr>
+          <p:cNvSpPr txBox="1"/>
+          <p:nvPr/>
+        </p:nvSpPr>
+        <p:spPr>
+          <a:xfrm rot="5400000">
+            <a:off x="4200989" y="2568425"/>
+            <a:ext cx="532272" cy="215444"/>
+          </a:xfrm>
+          <a:prstGeom prst="rect">
+            <a:avLst/>
+          </a:prstGeom>
+          <a:noFill/>
+        </p:spPr>
+        <p:txBody>
+          <a:bodyPr wrap="square" rtlCol="0">
+            <a:spAutoFit/>
+          </a:bodyPr>
+          <a:lstStyle/>
+          <a:p>
+            <a:r>
+              <a:rPr lang="en-US" sz="800" dirty="0"/>
+              <a:t>To FGR </a:t>
+            </a:r>
+          </a:p>
+        </p:txBody>
+      </p:sp>
+      <p:sp>
+        <p:nvSpPr>
+          <p:cNvPr id="66" name="TextBox 65">
+            <a:extLst>
+              <a:ext uri="{FF2B5EF4-FFF2-40B4-BE49-F238E27FC236}">
+                <a16:creationId xmlns:a16="http://schemas.microsoft.com/office/drawing/2014/main" id="{B50B5A89-0042-D099-55B8-9CA3587F54D1}"/>
+              </a:ext>
+            </a:extLst>
+          </p:cNvPr>
+          <p:cNvSpPr txBox="1"/>
+          <p:nvPr/>
+        </p:nvSpPr>
+        <p:spPr>
+          <a:xfrm rot="5400000">
+            <a:off x="4305959" y="2565792"/>
+            <a:ext cx="532272" cy="215444"/>
+          </a:xfrm>
+          <a:prstGeom prst="rect">
+            <a:avLst/>
+          </a:prstGeom>
+          <a:noFill/>
+        </p:spPr>
+        <p:txBody>
+          <a:bodyPr wrap="square" rtlCol="0">
+            <a:spAutoFit/>
+          </a:bodyPr>
+          <a:lstStyle/>
+          <a:p>
+            <a:r>
+              <a:rPr lang="en-US" sz="800" dirty="0"/>
+              <a:t>To FGR </a:t>
+            </a:r>
+          </a:p>
+        </p:txBody>
+      </p:sp>
+      <p:cxnSp>
+        <p:nvCxnSpPr>
+          <p:cNvPr id="70" name="Straight Connector 69">
+            <a:extLst>
+              <a:ext uri="{FF2B5EF4-FFF2-40B4-BE49-F238E27FC236}">
+                <a16:creationId xmlns:a16="http://schemas.microsoft.com/office/drawing/2014/main" id="{DBF561A3-7E8A-717E-C6EF-5DB769C1565A}"/>
+              </a:ext>
+            </a:extLst>
+          </p:cNvPr>
+          <p:cNvCxnSpPr>
+            <a:cxnSpLocks/>
+          </p:cNvCxnSpPr>
+          <p:nvPr/>
+        </p:nvCxnSpPr>
+        <p:spPr>
+          <a:xfrm>
+            <a:off x="4093214" y="1263290"/>
+            <a:ext cx="0" cy="178944"/>
+          </a:xfrm>
+          <a:prstGeom prst="line">
+            <a:avLst/>
+          </a:prstGeom>
+          <a:ln>
+            <a:solidFill>
+              <a:srgbClr val="FF0000"/>
+            </a:solidFill>
+          </a:ln>
+        </p:spPr>
+        <p:style>
+          <a:lnRef idx="2">
+            <a:schemeClr val="accent1"/>
+          </a:lnRef>
+          <a:fillRef idx="0">
+            <a:schemeClr val="accent1"/>
+          </a:fillRef>
+          <a:effectRef idx="1">
+            <a:schemeClr val="accent1"/>
+          </a:effectRef>
+          <a:fontRef idx="minor">
+            <a:schemeClr val="tx1"/>
+          </a:fontRef>
+        </p:style>
+      </p:cxnSp>
+      <p:cxnSp>
+        <p:nvCxnSpPr>
+          <p:cNvPr id="72" name="Straight Connector 71">
+            <a:extLst>
+              <a:ext uri="{FF2B5EF4-FFF2-40B4-BE49-F238E27FC236}">
+                <a16:creationId xmlns:a16="http://schemas.microsoft.com/office/drawing/2014/main" id="{CA94FC56-32E7-C791-F158-B0DDBD2C4D84}"/>
+              </a:ext>
+            </a:extLst>
+          </p:cNvPr>
+          <p:cNvCxnSpPr>
+            <a:cxnSpLocks/>
+          </p:cNvCxnSpPr>
+          <p:nvPr/>
+        </p:nvCxnSpPr>
+        <p:spPr>
+          <a:xfrm>
+            <a:off x="4340821" y="1266318"/>
+            <a:ext cx="0" cy="178944"/>
+          </a:xfrm>
+          <a:prstGeom prst="line">
+            <a:avLst/>
+          </a:prstGeom>
+          <a:ln>
+            <a:solidFill>
+              <a:schemeClr val="tx2">
+                <a:lumMod val="75000"/>
+                <a:lumOff val="25000"/>
+              </a:schemeClr>
+            </a:solidFill>
+          </a:ln>
+        </p:spPr>
+        <p:style>
+          <a:lnRef idx="2">
+            <a:schemeClr val="accent1"/>
+          </a:lnRef>
+          <a:fillRef idx="0">
+            <a:schemeClr val="accent1"/>
+          </a:fillRef>
+          <a:effectRef idx="1">
+            <a:schemeClr val="accent1"/>
+          </a:effectRef>
+          <a:fontRef idx="minor">
+            <a:schemeClr val="tx1"/>
+          </a:fontRef>
+        </p:style>
+      </p:cxnSp>
+      <p:cxnSp>
+        <p:nvCxnSpPr>
+          <p:cNvPr id="73" name="Straight Connector 72">
+            <a:extLst>
+              <a:ext uri="{FF2B5EF4-FFF2-40B4-BE49-F238E27FC236}">
+                <a16:creationId xmlns:a16="http://schemas.microsoft.com/office/drawing/2014/main" id="{FB512AAA-5AB0-8D42-6ED7-4199A4DB0E4B}"/>
+              </a:ext>
+            </a:extLst>
+          </p:cNvPr>
+          <p:cNvCxnSpPr>
+            <a:cxnSpLocks/>
+          </p:cNvCxnSpPr>
+          <p:nvPr/>
+        </p:nvCxnSpPr>
+        <p:spPr>
+          <a:xfrm>
+            <a:off x="4184832" y="1263290"/>
+            <a:ext cx="0" cy="178944"/>
+          </a:xfrm>
+          <a:prstGeom prst="line">
+            <a:avLst/>
+          </a:prstGeom>
+          <a:ln>
+            <a:solidFill>
+              <a:srgbClr val="FFC000"/>
+            </a:solidFill>
+          </a:ln>
+        </p:spPr>
+        <p:style>
+          <a:lnRef idx="2">
+            <a:schemeClr val="accent1"/>
+          </a:lnRef>
+          <a:fillRef idx="0">
+            <a:schemeClr val="accent1"/>
+          </a:fillRef>
+          <a:effectRef idx="1">
+            <a:schemeClr val="accent1"/>
+          </a:effectRef>
+          <a:fontRef idx="minor">
+            <a:schemeClr val="tx1"/>
+          </a:fontRef>
+        </p:style>
+      </p:cxnSp>
+      <p:cxnSp>
+        <p:nvCxnSpPr>
+          <p:cNvPr id="74" name="Straight Connector 73">
+            <a:extLst>
+              <a:ext uri="{FF2B5EF4-FFF2-40B4-BE49-F238E27FC236}">
+                <a16:creationId xmlns:a16="http://schemas.microsoft.com/office/drawing/2014/main" id="{34816B3B-124A-A7DC-225B-6124DDA3F872}"/>
+              </a:ext>
+            </a:extLst>
+          </p:cNvPr>
+          <p:cNvCxnSpPr>
+            <a:cxnSpLocks/>
+          </p:cNvCxnSpPr>
+          <p:nvPr/>
+        </p:nvCxnSpPr>
+        <p:spPr>
+          <a:xfrm>
+            <a:off x="4430766" y="1267038"/>
+            <a:ext cx="0" cy="178944"/>
+          </a:xfrm>
+          <a:prstGeom prst="line">
+            <a:avLst/>
+          </a:prstGeom>
+          <a:ln>
+            <a:solidFill>
+              <a:srgbClr val="FF0000"/>
+            </a:solidFill>
+          </a:ln>
+        </p:spPr>
+        <p:style>
+          <a:lnRef idx="2">
+            <a:schemeClr val="accent1"/>
+          </a:lnRef>
+          <a:fillRef idx="0">
+            <a:schemeClr val="accent1"/>
+          </a:fillRef>
+          <a:effectRef idx="1">
+            <a:schemeClr val="accent1"/>
+          </a:effectRef>
+          <a:fontRef idx="minor">
+            <a:schemeClr val="tx1"/>
+          </a:fontRef>
+        </p:style>
+      </p:cxnSp>
+      <p:cxnSp>
+        <p:nvCxnSpPr>
+          <p:cNvPr id="75" name="Straight Connector 74">
+            <a:extLst>
+              <a:ext uri="{FF2B5EF4-FFF2-40B4-BE49-F238E27FC236}">
+                <a16:creationId xmlns:a16="http://schemas.microsoft.com/office/drawing/2014/main" id="{9999CD95-8763-AAE8-BBF0-961FC398CE9B}"/>
+              </a:ext>
+            </a:extLst>
+          </p:cNvPr>
+          <p:cNvCxnSpPr>
+            <a:cxnSpLocks/>
+          </p:cNvCxnSpPr>
+          <p:nvPr/>
+        </p:nvCxnSpPr>
+        <p:spPr>
+          <a:xfrm>
+            <a:off x="4629601" y="1267943"/>
+            <a:ext cx="0" cy="178944"/>
+          </a:xfrm>
+          <a:prstGeom prst="line">
+            <a:avLst/>
+          </a:prstGeom>
+          <a:ln>
+            <a:solidFill>
+              <a:schemeClr val="accent3">
+                <a:lumMod val="60000"/>
+                <a:lumOff val="40000"/>
+              </a:schemeClr>
+            </a:solidFill>
+          </a:ln>
+        </p:spPr>
+        <p:style>
+          <a:lnRef idx="2">
+            <a:schemeClr val="accent1"/>
+          </a:lnRef>
+          <a:fillRef idx="0">
+            <a:schemeClr val="accent1"/>
+          </a:fillRef>
+          <a:effectRef idx="1">
+            <a:schemeClr val="accent1"/>
+          </a:effectRef>
+          <a:fontRef idx="minor">
+            <a:schemeClr val="tx1"/>
+          </a:fontRef>
+        </p:style>
+      </p:cxnSp>
+      <p:cxnSp>
+        <p:nvCxnSpPr>
+          <p:cNvPr id="76" name="Straight Connector 75">
+            <a:extLst>
+              <a:ext uri="{FF2B5EF4-FFF2-40B4-BE49-F238E27FC236}">
+                <a16:creationId xmlns:a16="http://schemas.microsoft.com/office/drawing/2014/main" id="{6748737E-39A6-0509-69C0-7B3FF2B03873}"/>
+              </a:ext>
+            </a:extLst>
+          </p:cNvPr>
+          <p:cNvCxnSpPr>
+            <a:cxnSpLocks/>
+          </p:cNvCxnSpPr>
+          <p:nvPr/>
+        </p:nvCxnSpPr>
+        <p:spPr>
+          <a:xfrm>
+            <a:off x="4708304" y="1263290"/>
+            <a:ext cx="0" cy="178944"/>
+          </a:xfrm>
+          <a:prstGeom prst="line">
+            <a:avLst/>
+          </a:prstGeom>
+          <a:ln>
+            <a:solidFill>
+              <a:schemeClr val="tx1"/>
+            </a:solidFill>
+          </a:ln>
+        </p:spPr>
+        <p:style>
+          <a:lnRef idx="2">
+            <a:schemeClr val="accent1"/>
+          </a:lnRef>
+          <a:fillRef idx="0">
+            <a:schemeClr val="accent1"/>
+          </a:fillRef>
+          <a:effectRef idx="1">
+            <a:schemeClr val="accent1"/>
+          </a:effectRef>
+          <a:fontRef idx="minor">
+            <a:schemeClr val="tx1"/>
+          </a:fontRef>
+        </p:style>
+      </p:cxnSp>
+      <p:sp>
+        <p:nvSpPr>
+          <p:cNvPr id="77" name="TextBox 76">
+            <a:extLst>
+              <a:ext uri="{FF2B5EF4-FFF2-40B4-BE49-F238E27FC236}">
+                <a16:creationId xmlns:a16="http://schemas.microsoft.com/office/drawing/2014/main" id="{77AF0A8F-3370-9852-41E1-0B21CB9DA4BC}"/>
+              </a:ext>
+            </a:extLst>
+          </p:cNvPr>
+          <p:cNvSpPr txBox="1"/>
+          <p:nvPr/>
+        </p:nvSpPr>
+        <p:spPr>
+          <a:xfrm rot="5400000">
+            <a:off x="3962099" y="899557"/>
+            <a:ext cx="738972" cy="215444"/>
+          </a:xfrm>
+          <a:prstGeom prst="rect">
+            <a:avLst/>
+          </a:prstGeom>
+          <a:noFill/>
+        </p:spPr>
+        <p:txBody>
+          <a:bodyPr wrap="square" rtlCol="0">
+            <a:spAutoFit/>
+          </a:bodyPr>
+          <a:lstStyle/>
+          <a:p>
+            <a:r>
+              <a:rPr lang="en-US" sz="800" dirty="0"/>
+              <a:t>Green Light</a:t>
+            </a:r>
+          </a:p>
+        </p:txBody>
+      </p:sp>
+      <p:sp>
+        <p:nvSpPr>
+          <p:cNvPr id="81" name="TextBox 80">
+            <a:extLst>
+              <a:ext uri="{FF2B5EF4-FFF2-40B4-BE49-F238E27FC236}">
+                <a16:creationId xmlns:a16="http://schemas.microsoft.com/office/drawing/2014/main" id="{313FB056-9BA1-9B79-0072-30D1AF8406C4}"/>
+              </a:ext>
+            </a:extLst>
+          </p:cNvPr>
+          <p:cNvSpPr txBox="1"/>
+          <p:nvPr/>
+        </p:nvSpPr>
+        <p:spPr>
+          <a:xfrm rot="5400000">
+            <a:off x="3997682" y="1061398"/>
+            <a:ext cx="362744" cy="215444"/>
+          </a:xfrm>
+          <a:prstGeom prst="rect">
+            <a:avLst/>
+          </a:prstGeom>
+          <a:noFill/>
+        </p:spPr>
+        <p:txBody>
+          <a:bodyPr wrap="square" rtlCol="0">
+            <a:spAutoFit/>
+          </a:bodyPr>
+          <a:lstStyle/>
+          <a:p>
+            <a:r>
+              <a:rPr lang="en-US" sz="800" dirty="0"/>
+              <a:t>-V</a:t>
+            </a:r>
+          </a:p>
+        </p:txBody>
+      </p:sp>
+      <p:sp>
+        <p:nvSpPr>
+          <p:cNvPr id="83" name="TextBox 82">
+            <a:extLst>
+              <a:ext uri="{FF2B5EF4-FFF2-40B4-BE49-F238E27FC236}">
+                <a16:creationId xmlns:a16="http://schemas.microsoft.com/office/drawing/2014/main" id="{74A196AA-9676-D654-3960-60EAE7AC5668}"/>
+              </a:ext>
+            </a:extLst>
+          </p:cNvPr>
+          <p:cNvSpPr txBox="1"/>
+          <p:nvPr/>
+        </p:nvSpPr>
+        <p:spPr>
+          <a:xfrm rot="5400000">
+            <a:off x="4102145" y="918186"/>
+            <a:ext cx="649169" cy="215444"/>
+          </a:xfrm>
+          <a:prstGeom prst="rect">
+            <a:avLst/>
+          </a:prstGeom>
+          <a:noFill/>
+        </p:spPr>
+        <p:txBody>
+          <a:bodyPr wrap="square" rtlCol="0">
+            <a:spAutoFit/>
+          </a:bodyPr>
+          <a:lstStyle/>
+          <a:p>
+            <a:r>
+              <a:rPr lang="en-US" sz="800" dirty="0"/>
+              <a:t>Red  Light</a:t>
+            </a:r>
+          </a:p>
+        </p:txBody>
+      </p:sp>
+      <p:sp>
+        <p:nvSpPr>
+          <p:cNvPr id="85" name="TextBox 84">
+            <a:extLst>
+              <a:ext uri="{FF2B5EF4-FFF2-40B4-BE49-F238E27FC236}">
+                <a16:creationId xmlns:a16="http://schemas.microsoft.com/office/drawing/2014/main" id="{70330ED3-19FF-3D34-73CA-B17EBB6244BA}"/>
+              </a:ext>
+            </a:extLst>
+          </p:cNvPr>
+          <p:cNvSpPr txBox="1"/>
+          <p:nvPr/>
+        </p:nvSpPr>
+        <p:spPr>
+          <a:xfrm rot="5400000">
+            <a:off x="4418142" y="1029947"/>
+            <a:ext cx="532272" cy="215444"/>
+          </a:xfrm>
+          <a:prstGeom prst="rect">
+            <a:avLst/>
+          </a:prstGeom>
+          <a:noFill/>
+        </p:spPr>
+        <p:txBody>
+          <a:bodyPr wrap="square" rtlCol="0">
+            <a:spAutoFit/>
+          </a:bodyPr>
+          <a:lstStyle/>
+          <a:p>
+            <a:r>
+              <a:rPr lang="en-US" sz="800" dirty="0" err="1"/>
+              <a:t>eStop</a:t>
+            </a:r>
+            <a:endParaRPr lang="en-US" sz="800" dirty="0"/>
+          </a:p>
+        </p:txBody>
+      </p:sp>
+      <p:grpSp>
+        <p:nvGrpSpPr>
+          <p:cNvPr id="90" name="Group 89">
+            <a:extLst>
+              <a:ext uri="{FF2B5EF4-FFF2-40B4-BE49-F238E27FC236}">
+                <a16:creationId xmlns:a16="http://schemas.microsoft.com/office/drawing/2014/main" id="{D4538FC6-8713-4299-981D-8EDC5A91FF90}"/>
+              </a:ext>
+            </a:extLst>
+          </p:cNvPr>
+          <p:cNvGrpSpPr/>
+          <p:nvPr/>
+        </p:nvGrpSpPr>
+        <p:grpSpPr>
+          <a:xfrm>
+            <a:off x="3877770" y="627176"/>
+            <a:ext cx="325664" cy="809371"/>
+            <a:chOff x="1319845" y="666221"/>
+            <a:chExt cx="325664" cy="809371"/>
+          </a:xfrm>
+        </p:grpSpPr>
+        <p:sp>
+          <p:nvSpPr>
+            <p:cNvPr id="87" name="TextBox 86">
+              <a:extLst>
+                <a:ext uri="{FF2B5EF4-FFF2-40B4-BE49-F238E27FC236}">
+                  <a16:creationId xmlns:a16="http://schemas.microsoft.com/office/drawing/2014/main" id="{42AB5A20-ACF1-E923-8DB2-08A3C13E39CD}"/>
+                </a:ext>
+              </a:extLst>
+            </p:cNvPr>
+            <p:cNvSpPr txBox="1"/>
+            <p:nvPr/>
+          </p:nvSpPr>
+          <p:spPr>
+            <a:xfrm rot="5400000">
+              <a:off x="1058081" y="927985"/>
+              <a:ext cx="738972" cy="215444"/>
+            </a:xfrm>
+            <a:prstGeom prst="rect">
+              <a:avLst/>
+            </a:prstGeom>
+            <a:noFill/>
+          </p:spPr>
+          <p:txBody>
+            <a:bodyPr wrap="square" rtlCol="0">
+              <a:spAutoFit/>
+            </a:bodyPr>
+            <a:lstStyle/>
+            <a:p>
+              <a:r>
+                <a:rPr lang="en-US" sz="800" dirty="0"/>
+                <a:t>Green Light</a:t>
+              </a:r>
+            </a:p>
+          </p:txBody>
+        </p:sp>
+        <p:sp>
+          <p:nvSpPr>
+            <p:cNvPr id="89" name="TextBox 88">
+              <a:extLst>
+                <a:ext uri="{FF2B5EF4-FFF2-40B4-BE49-F238E27FC236}">
+                  <a16:creationId xmlns:a16="http://schemas.microsoft.com/office/drawing/2014/main" id="{C69D1FA7-7D05-91C7-38CE-F231A3C4ED1C}"/>
+                </a:ext>
+              </a:extLst>
+            </p:cNvPr>
+            <p:cNvSpPr txBox="1"/>
+            <p:nvPr/>
+          </p:nvSpPr>
+          <p:spPr>
+            <a:xfrm rot="5400000">
+              <a:off x="1168301" y="998384"/>
+              <a:ext cx="738972" cy="215444"/>
+            </a:xfrm>
+            <a:prstGeom prst="rect">
+              <a:avLst/>
+            </a:prstGeom>
+            <a:noFill/>
+          </p:spPr>
+          <p:txBody>
+            <a:bodyPr wrap="square" rtlCol="0">
+              <a:spAutoFit/>
+            </a:bodyPr>
+            <a:lstStyle/>
+            <a:p>
+              <a:r>
+                <a:rPr lang="en-US" sz="800" dirty="0"/>
+                <a:t>Red  Light</a:t>
+              </a:r>
+            </a:p>
+          </p:txBody>
+        </p:sp>
+      </p:grpSp>
+      <p:cxnSp>
+        <p:nvCxnSpPr>
+          <p:cNvPr id="91" name="Straight Connector 90">
+            <a:extLst>
+              <a:ext uri="{FF2B5EF4-FFF2-40B4-BE49-F238E27FC236}">
+                <a16:creationId xmlns:a16="http://schemas.microsoft.com/office/drawing/2014/main" id="{AE469154-57AB-4AE4-0F52-0EFECE6A1DDE}"/>
+              </a:ext>
+            </a:extLst>
+          </p:cNvPr>
+          <p:cNvCxnSpPr>
+            <a:cxnSpLocks/>
+          </p:cNvCxnSpPr>
+          <p:nvPr/>
+        </p:nvCxnSpPr>
+        <p:spPr>
+          <a:xfrm>
+            <a:off x="4015489" y="1266528"/>
+            <a:ext cx="0" cy="178944"/>
+          </a:xfrm>
+          <a:prstGeom prst="line">
+            <a:avLst/>
+          </a:prstGeom>
+          <a:ln>
+            <a:solidFill>
+              <a:schemeClr val="tx2">
+                <a:lumMod val="75000"/>
+                <a:lumOff val="25000"/>
+              </a:schemeClr>
+            </a:solidFill>
+          </a:ln>
+        </p:spPr>
+        <p:style>
+          <a:lnRef idx="2">
+            <a:schemeClr val="accent1"/>
+          </a:lnRef>
+          <a:fillRef idx="0">
+            <a:schemeClr val="accent1"/>
+          </a:fillRef>
+          <a:effectRef idx="1">
+            <a:schemeClr val="accent1"/>
+          </a:effectRef>
+          <a:fontRef idx="minor">
+            <a:schemeClr val="tx1"/>
+          </a:fontRef>
+        </p:style>
+      </p:cxnSp>
+      <p:sp>
+        <p:nvSpPr>
+          <p:cNvPr id="94" name="TextBox 93">
+            <a:extLst>
+              <a:ext uri="{FF2B5EF4-FFF2-40B4-BE49-F238E27FC236}">
+                <a16:creationId xmlns:a16="http://schemas.microsoft.com/office/drawing/2014/main" id="{5DE5CE44-8D4A-1943-2485-32C7CFB7EDBE}"/>
+              </a:ext>
+            </a:extLst>
+          </p:cNvPr>
+          <p:cNvSpPr txBox="1"/>
+          <p:nvPr/>
+        </p:nvSpPr>
+        <p:spPr>
+          <a:xfrm>
+            <a:off x="2696403" y="1764658"/>
+            <a:ext cx="893956" cy="215444"/>
+          </a:xfrm>
+          <a:prstGeom prst="rect">
+            <a:avLst/>
+          </a:prstGeom>
+          <a:noFill/>
+        </p:spPr>
+        <p:txBody>
+          <a:bodyPr wrap="square" rtlCol="0">
+            <a:spAutoFit/>
+          </a:bodyPr>
+          <a:lstStyle/>
+          <a:p>
+            <a:r>
+              <a:rPr lang="en-US" sz="800" dirty="0"/>
+              <a:t>Note: Jumper</a:t>
+            </a:r>
+          </a:p>
+        </p:txBody>
+      </p:sp>
+      <p:sp>
+        <p:nvSpPr>
+          <p:cNvPr id="96" name="Arrow: Right 95">
+            <a:extLst>
+              <a:ext uri="{FF2B5EF4-FFF2-40B4-BE49-F238E27FC236}">
+                <a16:creationId xmlns:a16="http://schemas.microsoft.com/office/drawing/2014/main" id="{159D0EA2-4855-83FA-B685-0AA86085BAC7}"/>
+              </a:ext>
+            </a:extLst>
+          </p:cNvPr>
+          <p:cNvSpPr/>
+          <p:nvPr/>
+        </p:nvSpPr>
+        <p:spPr>
+          <a:xfrm>
+            <a:off x="3471484" y="1771120"/>
+            <a:ext cx="288121" cy="231729"/>
+          </a:xfrm>
+          <a:prstGeom prst="rightArrow">
+            <a:avLst/>
+          </a:prstGeom>
+        </p:spPr>
+        <p:style>
+          <a:lnRef idx="2">
+            <a:schemeClr val="accent1">
+              <a:shade val="15000"/>
+            </a:schemeClr>
+          </a:lnRef>
+          <a:fillRef idx="1">
+            <a:schemeClr val="accent1"/>
+          </a:fillRef>
+          <a:effectRef idx="0">
+            <a:schemeClr val="accent1"/>
+          </a:effectRef>
+          <a:fontRef idx="minor">
+            <a:schemeClr val="lt1"/>
+          </a:fontRef>
+        </p:style>
+        <p:txBody>
+          <a:bodyPr rtlCol="0" anchor="ctr"/>
+          <a:lstStyle/>
+          <a:p>
+            <a:pPr algn="ctr"/>
+            <a:endParaRPr lang="en-US"/>
+          </a:p>
+        </p:txBody>
+      </p:sp>
+      <p:cxnSp>
+        <p:nvCxnSpPr>
+          <p:cNvPr id="125" name="Straight Connector 124">
+            <a:extLst>
+              <a:ext uri="{FF2B5EF4-FFF2-40B4-BE49-F238E27FC236}">
+                <a16:creationId xmlns:a16="http://schemas.microsoft.com/office/drawing/2014/main" id="{54F0E6A7-AAE6-4A95-EE4F-67B279F54D71}"/>
+              </a:ext>
+            </a:extLst>
+          </p:cNvPr>
+          <p:cNvCxnSpPr>
+            <a:cxnSpLocks/>
+          </p:cNvCxnSpPr>
+          <p:nvPr/>
+        </p:nvCxnSpPr>
+        <p:spPr>
+          <a:xfrm flipH="1">
+            <a:off x="7581954" y="3845125"/>
+            <a:ext cx="256879" cy="0"/>
+          </a:xfrm>
+          <a:prstGeom prst="line">
+            <a:avLst/>
+          </a:prstGeom>
+          <a:ln>
+            <a:solidFill>
+              <a:schemeClr val="tx2">
+                <a:lumMod val="75000"/>
+                <a:lumOff val="25000"/>
+              </a:schemeClr>
+            </a:solidFill>
+          </a:ln>
+        </p:spPr>
+        <p:style>
+          <a:lnRef idx="2">
+            <a:schemeClr val="accent1"/>
+          </a:lnRef>
+          <a:fillRef idx="0">
+            <a:schemeClr val="accent1"/>
+          </a:fillRef>
+          <a:effectRef idx="1">
+            <a:schemeClr val="accent1"/>
+          </a:effectRef>
+          <a:fontRef idx="minor">
+            <a:schemeClr val="tx1"/>
+          </a:fontRef>
+        </p:style>
+      </p:cxnSp>
+      <p:cxnSp>
+        <p:nvCxnSpPr>
+          <p:cNvPr id="126" name="Straight Connector 125">
+            <a:extLst>
+              <a:ext uri="{FF2B5EF4-FFF2-40B4-BE49-F238E27FC236}">
+                <a16:creationId xmlns:a16="http://schemas.microsoft.com/office/drawing/2014/main" id="{11206650-5D37-27CE-BAFE-54E8098E63F4}"/>
+              </a:ext>
+            </a:extLst>
+          </p:cNvPr>
+          <p:cNvCxnSpPr>
+            <a:cxnSpLocks/>
+          </p:cNvCxnSpPr>
+          <p:nvPr/>
+        </p:nvCxnSpPr>
+        <p:spPr>
+          <a:xfrm flipH="1">
+            <a:off x="7585634" y="3750800"/>
+            <a:ext cx="253199" cy="0"/>
+          </a:xfrm>
+          <a:prstGeom prst="line">
+            <a:avLst/>
+          </a:prstGeom>
+          <a:ln>
+            <a:solidFill>
+              <a:srgbClr val="FFC000"/>
+            </a:solidFill>
+          </a:ln>
+        </p:spPr>
+        <p:style>
+          <a:lnRef idx="2">
+            <a:schemeClr val="accent1"/>
+          </a:lnRef>
+          <a:fillRef idx="0">
+            <a:schemeClr val="accent1"/>
+          </a:fillRef>
+          <a:effectRef idx="1">
+            <a:schemeClr val="accent1"/>
+          </a:effectRef>
+          <a:fontRef idx="minor">
+            <a:schemeClr val="tx1"/>
+          </a:fontRef>
+        </p:style>
+      </p:cxnSp>
+      <p:cxnSp>
+        <p:nvCxnSpPr>
+          <p:cNvPr id="127" name="Straight Connector 126">
+            <a:extLst>
+              <a:ext uri="{FF2B5EF4-FFF2-40B4-BE49-F238E27FC236}">
+                <a16:creationId xmlns:a16="http://schemas.microsoft.com/office/drawing/2014/main" id="{EBC04DAA-D571-63F8-D4D3-D071CCFDEA12}"/>
+              </a:ext>
+            </a:extLst>
+          </p:cNvPr>
+          <p:cNvCxnSpPr>
+            <a:cxnSpLocks/>
+          </p:cNvCxnSpPr>
+          <p:nvPr/>
+        </p:nvCxnSpPr>
+        <p:spPr>
+          <a:xfrm flipH="1">
+            <a:off x="7585367" y="3638347"/>
+            <a:ext cx="260527" cy="0"/>
+          </a:xfrm>
+          <a:prstGeom prst="line">
+            <a:avLst/>
+          </a:prstGeom>
+          <a:ln>
+            <a:solidFill>
+              <a:srgbClr val="FF0000"/>
+            </a:solidFill>
+          </a:ln>
+        </p:spPr>
+        <p:style>
+          <a:lnRef idx="2">
+            <a:schemeClr val="accent1"/>
+          </a:lnRef>
+          <a:fillRef idx="0">
+            <a:schemeClr val="accent1"/>
+          </a:fillRef>
+          <a:effectRef idx="1">
+            <a:schemeClr val="accent1"/>
+          </a:effectRef>
+          <a:fontRef idx="minor">
+            <a:schemeClr val="tx1"/>
+          </a:fontRef>
+        </p:style>
+      </p:cxnSp>
+      <p:cxnSp>
+        <p:nvCxnSpPr>
+          <p:cNvPr id="128" name="Straight Connector 127">
+            <a:extLst>
+              <a:ext uri="{FF2B5EF4-FFF2-40B4-BE49-F238E27FC236}">
+                <a16:creationId xmlns:a16="http://schemas.microsoft.com/office/drawing/2014/main" id="{E66DFAB4-AFED-0275-35C4-6A048FB131C9}"/>
+              </a:ext>
+            </a:extLst>
+          </p:cNvPr>
+          <p:cNvCxnSpPr>
+            <a:cxnSpLocks/>
+          </p:cNvCxnSpPr>
+          <p:nvPr/>
+        </p:nvCxnSpPr>
+        <p:spPr>
+          <a:xfrm flipH="1">
+            <a:off x="7584436" y="3437749"/>
+            <a:ext cx="240275" cy="0"/>
+          </a:xfrm>
+          <a:prstGeom prst="line">
+            <a:avLst/>
+          </a:prstGeom>
+          <a:ln>
+            <a:solidFill>
+              <a:schemeClr val="accent3">
+                <a:lumMod val="60000"/>
+                <a:lumOff val="40000"/>
+              </a:schemeClr>
+            </a:solidFill>
+          </a:ln>
+        </p:spPr>
+        <p:style>
+          <a:lnRef idx="2">
+            <a:schemeClr val="accent1"/>
+          </a:lnRef>
+          <a:fillRef idx="0">
+            <a:schemeClr val="accent1"/>
+          </a:fillRef>
+          <a:effectRef idx="1">
+            <a:schemeClr val="accent1"/>
+          </a:effectRef>
+          <a:fontRef idx="minor">
+            <a:schemeClr val="tx1"/>
+          </a:fontRef>
+        </p:style>
+      </p:cxnSp>
+      <p:cxnSp>
+        <p:nvCxnSpPr>
+          <p:cNvPr id="131" name="Straight Connector 130">
+            <a:extLst>
+              <a:ext uri="{FF2B5EF4-FFF2-40B4-BE49-F238E27FC236}">
+                <a16:creationId xmlns:a16="http://schemas.microsoft.com/office/drawing/2014/main" id="{95B0C9B7-EFFF-DD51-6C91-13403D9491E4}"/>
+              </a:ext>
+            </a:extLst>
+          </p:cNvPr>
+          <p:cNvCxnSpPr>
+            <a:cxnSpLocks/>
+          </p:cNvCxnSpPr>
+          <p:nvPr/>
+        </p:nvCxnSpPr>
+        <p:spPr>
+          <a:xfrm flipH="1">
+            <a:off x="7585468" y="3533341"/>
+            <a:ext cx="249834" cy="0"/>
+          </a:xfrm>
+          <a:prstGeom prst="line">
+            <a:avLst/>
+          </a:prstGeom>
+          <a:ln>
+            <a:solidFill>
+              <a:schemeClr val="tx1"/>
+            </a:solidFill>
+          </a:ln>
+        </p:spPr>
+        <p:style>
+          <a:lnRef idx="2">
+            <a:schemeClr val="accent1"/>
+          </a:lnRef>
+          <a:fillRef idx="0">
+            <a:schemeClr val="accent1"/>
+          </a:fillRef>
+          <a:effectRef idx="1">
+            <a:schemeClr val="accent1"/>
+          </a:effectRef>
+          <a:fontRef idx="minor">
+            <a:schemeClr val="tx1"/>
+          </a:fontRef>
+        </p:style>
+      </p:cxnSp>
+      <p:sp>
+        <p:nvSpPr>
+          <p:cNvPr id="137" name="TextBox 136">
+            <a:extLst>
+              <a:ext uri="{FF2B5EF4-FFF2-40B4-BE49-F238E27FC236}">
+                <a16:creationId xmlns:a16="http://schemas.microsoft.com/office/drawing/2014/main" id="{37DB7448-77FE-0ADD-6041-612D25C50615}"/>
+              </a:ext>
+            </a:extLst>
+          </p:cNvPr>
+          <p:cNvSpPr txBox="1"/>
+          <p:nvPr/>
+        </p:nvSpPr>
+        <p:spPr>
+          <a:xfrm>
+            <a:off x="7067159" y="3388827"/>
+            <a:ext cx="650429" cy="461665"/>
+          </a:xfrm>
+          <a:prstGeom prst="rect">
+            <a:avLst/>
+          </a:prstGeom>
+          <a:noFill/>
+        </p:spPr>
+        <p:txBody>
+          <a:bodyPr wrap="square" rtlCol="0">
+            <a:spAutoFit/>
+          </a:bodyPr>
+          <a:lstStyle/>
+          <a:p>
+            <a:r>
+              <a:rPr lang="en-US" sz="800" dirty="0"/>
+              <a:t>To Terminal Block</a:t>
+            </a:r>
+          </a:p>
+        </p:txBody>
+      </p:sp>
+      <p:cxnSp>
+        <p:nvCxnSpPr>
+          <p:cNvPr id="179" name="Straight Connector 178">
+            <a:extLst>
+              <a:ext uri="{FF2B5EF4-FFF2-40B4-BE49-F238E27FC236}">
+                <a16:creationId xmlns:a16="http://schemas.microsoft.com/office/drawing/2014/main" id="{73119F21-2C2B-F374-4EB7-CF9371F3A7DA}"/>
+              </a:ext>
+            </a:extLst>
+          </p:cNvPr>
+          <p:cNvCxnSpPr>
+            <a:cxnSpLocks/>
+          </p:cNvCxnSpPr>
+          <p:nvPr/>
+        </p:nvCxnSpPr>
+        <p:spPr>
+          <a:xfrm>
+            <a:off x="7501873" y="1740659"/>
+            <a:ext cx="571094" cy="0"/>
+          </a:xfrm>
+          <a:prstGeom prst="line">
+            <a:avLst/>
+          </a:prstGeom>
+          <a:ln>
+            <a:solidFill>
+              <a:schemeClr val="tx1"/>
+            </a:solidFill>
+          </a:ln>
+        </p:spPr>
+        <p:style>
+          <a:lnRef idx="2">
+            <a:schemeClr val="accent1"/>
+          </a:lnRef>
+          <a:fillRef idx="0">
+            <a:schemeClr val="accent1"/>
+          </a:fillRef>
+          <a:effectRef idx="1">
+            <a:schemeClr val="accent1"/>
+          </a:effectRef>
+          <a:fontRef idx="minor">
+            <a:schemeClr val="tx1"/>
+          </a:fontRef>
+        </p:style>
+      </p:cxnSp>
+      <p:cxnSp>
+        <p:nvCxnSpPr>
+          <p:cNvPr id="196" name="Straight Connector 195">
+            <a:extLst>
+              <a:ext uri="{FF2B5EF4-FFF2-40B4-BE49-F238E27FC236}">
+                <a16:creationId xmlns:a16="http://schemas.microsoft.com/office/drawing/2014/main" id="{B9561AB7-B914-C674-BFC2-D3882A8BC1B1}"/>
+              </a:ext>
+            </a:extLst>
+          </p:cNvPr>
+          <p:cNvCxnSpPr>
+            <a:cxnSpLocks/>
+          </p:cNvCxnSpPr>
+          <p:nvPr/>
+        </p:nvCxnSpPr>
+        <p:spPr>
+          <a:xfrm>
+            <a:off x="7489886" y="1740659"/>
+            <a:ext cx="0" cy="219292"/>
+          </a:xfrm>
+          <a:prstGeom prst="line">
+            <a:avLst/>
+          </a:prstGeom>
+          <a:ln>
+            <a:solidFill>
+              <a:schemeClr val="tx1"/>
+            </a:solidFill>
+          </a:ln>
+        </p:spPr>
+        <p:style>
+          <a:lnRef idx="2">
+            <a:schemeClr val="accent1"/>
+          </a:lnRef>
+          <a:fillRef idx="0">
+            <a:schemeClr val="accent1"/>
+          </a:fillRef>
+          <a:effectRef idx="1">
+            <a:schemeClr val="accent1"/>
+          </a:effectRef>
+          <a:fontRef idx="minor">
+            <a:schemeClr val="tx1"/>
+          </a:fontRef>
+        </p:style>
+      </p:cxnSp>
+      <p:cxnSp>
+        <p:nvCxnSpPr>
+          <p:cNvPr id="197" name="Straight Connector 196">
+            <a:extLst>
+              <a:ext uri="{FF2B5EF4-FFF2-40B4-BE49-F238E27FC236}">
+                <a16:creationId xmlns:a16="http://schemas.microsoft.com/office/drawing/2014/main" id="{7C61A36F-E26F-9B44-CDEC-4BD04B99CC99}"/>
+              </a:ext>
+            </a:extLst>
+          </p:cNvPr>
+          <p:cNvCxnSpPr>
+            <a:cxnSpLocks/>
+          </p:cNvCxnSpPr>
+          <p:nvPr/>
+        </p:nvCxnSpPr>
+        <p:spPr>
+          <a:xfrm>
+            <a:off x="7736265" y="1940182"/>
+            <a:ext cx="315535" cy="0"/>
+          </a:xfrm>
+          <a:prstGeom prst="line">
+            <a:avLst/>
+          </a:prstGeom>
+          <a:ln>
+            <a:solidFill>
+              <a:schemeClr val="tx2">
+                <a:lumMod val="75000"/>
+                <a:lumOff val="25000"/>
+              </a:schemeClr>
+            </a:solidFill>
+          </a:ln>
+        </p:spPr>
+        <p:style>
+          <a:lnRef idx="2">
+            <a:schemeClr val="accent1"/>
+          </a:lnRef>
+          <a:fillRef idx="0">
+            <a:schemeClr val="accent1"/>
+          </a:fillRef>
+          <a:effectRef idx="1">
+            <a:schemeClr val="accent1"/>
+          </a:effectRef>
+          <a:fontRef idx="minor">
+            <a:schemeClr val="tx1"/>
+          </a:fontRef>
+        </p:style>
+      </p:cxnSp>
+      <p:cxnSp>
+        <p:nvCxnSpPr>
+          <p:cNvPr id="198" name="Straight Connector 197">
+            <a:extLst>
+              <a:ext uri="{FF2B5EF4-FFF2-40B4-BE49-F238E27FC236}">
+                <a16:creationId xmlns:a16="http://schemas.microsoft.com/office/drawing/2014/main" id="{2B196837-F04A-2235-9EB3-16105534236A}"/>
+              </a:ext>
+            </a:extLst>
+          </p:cNvPr>
+          <p:cNvCxnSpPr>
+            <a:cxnSpLocks/>
+          </p:cNvCxnSpPr>
+          <p:nvPr/>
+        </p:nvCxnSpPr>
+        <p:spPr>
+          <a:xfrm>
+            <a:off x="7724278" y="1940182"/>
+            <a:ext cx="0" cy="219292"/>
+          </a:xfrm>
+          <a:prstGeom prst="line">
+            <a:avLst/>
+          </a:prstGeom>
+          <a:ln>
+            <a:solidFill>
+              <a:schemeClr val="tx2">
+                <a:lumMod val="75000"/>
+                <a:lumOff val="25000"/>
+              </a:schemeClr>
+            </a:solidFill>
+          </a:ln>
+        </p:spPr>
+        <p:style>
+          <a:lnRef idx="2">
+            <a:schemeClr val="accent1"/>
+          </a:lnRef>
+          <a:fillRef idx="0">
+            <a:schemeClr val="accent1"/>
+          </a:fillRef>
+          <a:effectRef idx="1">
+            <a:schemeClr val="accent1"/>
+          </a:effectRef>
+          <a:fontRef idx="minor">
+            <a:schemeClr val="tx1"/>
+          </a:fontRef>
+        </p:style>
+      </p:cxnSp>
+      <p:sp>
+        <p:nvSpPr>
+          <p:cNvPr id="209" name="TextBox 208">
+            <a:extLst>
+              <a:ext uri="{FF2B5EF4-FFF2-40B4-BE49-F238E27FC236}">
+                <a16:creationId xmlns:a16="http://schemas.microsoft.com/office/drawing/2014/main" id="{7A0BC6D1-C31A-C0C1-7588-E5333C3B19DE}"/>
+              </a:ext>
+            </a:extLst>
+          </p:cNvPr>
+          <p:cNvSpPr txBox="1"/>
+          <p:nvPr/>
+        </p:nvSpPr>
+        <p:spPr>
+          <a:xfrm>
+            <a:off x="7489886" y="1753777"/>
+            <a:ext cx="697978" cy="215444"/>
+          </a:xfrm>
+          <a:prstGeom prst="rect">
+            <a:avLst/>
+          </a:prstGeom>
+          <a:noFill/>
+        </p:spPr>
+        <p:txBody>
+          <a:bodyPr wrap="square" rtlCol="0">
+            <a:spAutoFit/>
+          </a:bodyPr>
+          <a:lstStyle>
+            <a:defPPr>
+              <a:defRPr lang="en-US"/>
+            </a:defPPr>
+            <a:lvl1pPr>
+              <a:defRPr sz="800"/>
+            </a:lvl1pPr>
+          </a:lstStyle>
+          <a:p>
+            <a:r>
+              <a:rPr lang="en-US" dirty="0"/>
+              <a:t>Green Light</a:t>
+            </a:r>
+          </a:p>
+        </p:txBody>
+      </p:sp>
+      <p:sp>
+        <p:nvSpPr>
+          <p:cNvPr id="213" name="TextBox 212">
+            <a:extLst>
+              <a:ext uri="{FF2B5EF4-FFF2-40B4-BE49-F238E27FC236}">
+                <a16:creationId xmlns:a16="http://schemas.microsoft.com/office/drawing/2014/main" id="{AC1DC220-881F-6798-CA52-2B0713512E31}"/>
+              </a:ext>
+            </a:extLst>
+          </p:cNvPr>
+          <p:cNvSpPr txBox="1"/>
+          <p:nvPr/>
+        </p:nvSpPr>
+        <p:spPr>
+          <a:xfrm>
+            <a:off x="9475599" y="1852229"/>
+            <a:ext cx="1120107" cy="215444"/>
+          </a:xfrm>
+          <a:prstGeom prst="rect">
+            <a:avLst/>
+          </a:prstGeom>
+          <a:noFill/>
+        </p:spPr>
+        <p:txBody>
+          <a:bodyPr wrap="square" rtlCol="0">
+            <a:spAutoFit/>
+          </a:bodyPr>
+          <a:lstStyle/>
+          <a:p>
+            <a:r>
+              <a:rPr lang="en-US" sz="800" dirty="0"/>
+              <a:t>To Terminal Block</a:t>
+            </a:r>
+          </a:p>
+        </p:txBody>
+      </p:sp>
+      <p:sp>
+        <p:nvSpPr>
+          <p:cNvPr id="215" name="TextBox 214">
+            <a:extLst>
+              <a:ext uri="{FF2B5EF4-FFF2-40B4-BE49-F238E27FC236}">
+                <a16:creationId xmlns:a16="http://schemas.microsoft.com/office/drawing/2014/main" id="{E50F5F3D-A5E7-4DDE-4E84-66B048CFACDC}"/>
+              </a:ext>
+            </a:extLst>
+          </p:cNvPr>
+          <p:cNvSpPr txBox="1"/>
+          <p:nvPr/>
+        </p:nvSpPr>
+        <p:spPr>
+          <a:xfrm rot="2108879">
+            <a:off x="6902977" y="1956466"/>
+            <a:ext cx="1120107" cy="215444"/>
+          </a:xfrm>
+          <a:prstGeom prst="rect">
+            <a:avLst/>
+          </a:prstGeom>
+          <a:noFill/>
+        </p:spPr>
+        <p:txBody>
+          <a:bodyPr wrap="square" rtlCol="0">
+            <a:spAutoFit/>
+          </a:bodyPr>
+          <a:lstStyle/>
+          <a:p>
+            <a:r>
+              <a:rPr lang="en-US" sz="800" dirty="0"/>
+              <a:t>To Terminal Block</a:t>
+            </a:r>
+          </a:p>
+        </p:txBody>
+      </p:sp>
+      <p:sp>
+        <p:nvSpPr>
+          <p:cNvPr id="4" name="TextBox 3">
+            <a:extLst>
+              <a:ext uri="{FF2B5EF4-FFF2-40B4-BE49-F238E27FC236}">
+                <a16:creationId xmlns:a16="http://schemas.microsoft.com/office/drawing/2014/main" id="{19E060F9-204C-56DD-90AC-BD8F46779478}"/>
+              </a:ext>
+            </a:extLst>
+          </p:cNvPr>
+          <p:cNvSpPr txBox="1"/>
+          <p:nvPr/>
+        </p:nvSpPr>
+        <p:spPr>
+          <a:xfrm rot="5400000">
+            <a:off x="3886447" y="2562797"/>
+            <a:ext cx="532272" cy="215444"/>
+          </a:xfrm>
+          <a:prstGeom prst="rect">
+            <a:avLst/>
+          </a:prstGeom>
+          <a:noFill/>
+        </p:spPr>
+        <p:txBody>
+          <a:bodyPr wrap="square" rtlCol="0">
+            <a:spAutoFit/>
+          </a:bodyPr>
+          <a:lstStyle/>
+          <a:p>
+            <a:r>
+              <a:rPr lang="en-US" sz="800" dirty="0"/>
+              <a:t>To FGR </a:t>
+            </a:r>
+          </a:p>
+        </p:txBody>
+      </p:sp>
+      <p:pic>
+        <p:nvPicPr>
+          <p:cNvPr id="8" name="Picture 7">
+            <a:extLst>
+              <a:ext uri="{FF2B5EF4-FFF2-40B4-BE49-F238E27FC236}">
+                <a16:creationId xmlns:a16="http://schemas.microsoft.com/office/drawing/2014/main" id="{D96579F5-DEB3-30E2-6220-C5933B0C9DB9}"/>
+              </a:ext>
+            </a:extLst>
+          </p:cNvPr>
+          <p:cNvPicPr>
+            <a:picLocks noChangeAspect="1"/>
+          </p:cNvPicPr>
+          <p:nvPr/>
+        </p:nvPicPr>
+        <p:blipFill>
+          <a:blip r:embed="rId6"/>
+          <a:stretch>
+            <a:fillRect/>
+          </a:stretch>
+        </p:blipFill>
+        <p:spPr>
+          <a:xfrm>
+            <a:off x="3773581" y="1488855"/>
+            <a:ext cx="972270" cy="785753"/>
+          </a:xfrm>
+          <a:prstGeom prst="rect">
+            <a:avLst/>
+          </a:prstGeom>
+        </p:spPr>
+      </p:pic>
+      <p:pic>
+        <p:nvPicPr>
+          <p:cNvPr id="13" name="Picture 12">
+            <a:extLst>
+              <a:ext uri="{FF2B5EF4-FFF2-40B4-BE49-F238E27FC236}">
+                <a16:creationId xmlns:a16="http://schemas.microsoft.com/office/drawing/2014/main" id="{C51A87AB-F9AC-2BD0-1D57-8020F328F367}"/>
+              </a:ext>
+            </a:extLst>
+          </p:cNvPr>
+          <p:cNvPicPr>
+            <a:picLocks noChangeAspect="1"/>
+          </p:cNvPicPr>
+          <p:nvPr/>
+        </p:nvPicPr>
+        <p:blipFill>
+          <a:blip r:embed="rId7"/>
+          <a:stretch>
+            <a:fillRect/>
+          </a:stretch>
+        </p:blipFill>
+        <p:spPr>
+          <a:xfrm>
+            <a:off x="7919235" y="2849007"/>
+            <a:ext cx="1158479" cy="1286571"/>
+          </a:xfrm>
+          <a:prstGeom prst="rect">
+            <a:avLst/>
+          </a:prstGeom>
+        </p:spPr>
+      </p:pic>
+    </p:spTree>
+    <p:extLst>
+      <p:ext uri="{BB962C8B-B14F-4D97-AF65-F5344CB8AC3E}">
+        <p14:creationId xmlns:p14="http://schemas.microsoft.com/office/powerpoint/2010/main" val="284534981"/>
       </p:ext>
     </p:extLst>
   </p:cSld>

</xml_diff>